<commit_message>
created book and genre app, created author.model, views for creating and displaying authors
</commit_message>
<xml_diff>
--- a/LMS backend design.pptx
+++ b/LMS backend design.pptx
@@ -104,6 +104,11 @@
       </a:defRPr>
     </a:lvl9pPr>
   </p:defaultTextStyle>
+  <p:extLst>
+    <p:ext uri="{EFAFB233-063F-42B5-8137-9DF3F51BA10A}">
+      <p15:sldGuideLst xmlns:p15="http://schemas.microsoft.com/office/powerpoint/2012/main"/>
+    </p:ext>
+  </p:extLst>
 </p:presentation>
 </file>
 
@@ -3336,6 +3341,186 @@
         <p:spPr>
           <a:xfrm>
             <a:off x="3562494" y="1124923"/>
+            <a:ext cx="2059557" cy="1384995"/>
+          </a:xfrm>
+          <a:prstGeom prst="rect">
+            <a:avLst/>
+          </a:prstGeom>
+          <a:noFill/>
+          <a:ln>
+            <a:solidFill>
+              <a:schemeClr val="accent1">
+                <a:lumMod val="50000"/>
+              </a:schemeClr>
+            </a:solidFill>
+          </a:ln>
+        </p:spPr>
+        <p:txBody>
+          <a:bodyPr wrap="square">
+            <a:spAutoFit/>
+          </a:bodyPr>
+          <a:lstStyle/>
+          <a:p>
+            <a:pPr marL="0" marR="0">
+              <a:spcBef>
+                <a:spcPts val="0"/>
+              </a:spcBef>
+              <a:spcAft>
+                <a:spcPts val="0"/>
+              </a:spcAft>
+            </a:pPr>
+            <a:r>
+              <a:rPr lang="en-US" sz="1400" dirty="0">
+                <a:effectLst/>
+                <a:latin typeface="Century Gothic" panose="020B0502020202020204" pitchFamily="34" charset="0"/>
+              </a:rPr>
+              <a:t>User Profile</a:t>
+            </a:r>
+          </a:p>
+          <a:p>
+            <a:pPr marL="285750" indent="-285750" rtl="0" fontAlgn="ctr">
+              <a:spcBef>
+                <a:spcPts val="0"/>
+              </a:spcBef>
+              <a:spcAft>
+                <a:spcPts val="0"/>
+              </a:spcAft>
+              <a:buFont typeface="Arial" panose="020B0604020202020204" pitchFamily="34" charset="0"/>
+              <a:buChar char="•"/>
+            </a:pPr>
+            <a:r>
+              <a:rPr lang="en-US" sz="1400" dirty="0" err="1">
+                <a:effectLst/>
+                <a:latin typeface="Century Gothic" panose="020B0502020202020204" pitchFamily="34" charset="0"/>
+              </a:rPr>
+              <a:t>user</a:t>
+            </a:r>
+            <a:r>
+              <a:rPr lang="en-US" sz="1400" dirty="0" err="1">
+                <a:latin typeface="Century Gothic" panose="020B0502020202020204" pitchFamily="34" charset="0"/>
+              </a:rPr>
+              <a:t>_</a:t>
+            </a:r>
+            <a:r>
+              <a:rPr lang="en-US" sz="1400" dirty="0" err="1">
+                <a:effectLst/>
+                <a:latin typeface="Century Gothic" panose="020B0502020202020204" pitchFamily="34" charset="0"/>
+              </a:rPr>
+              <a:t>id</a:t>
+            </a:r>
+            <a:r>
+              <a:rPr lang="en-US" sz="1400" dirty="0">
+                <a:effectLst/>
+                <a:latin typeface="Century Gothic" panose="020B0502020202020204" pitchFamily="34" charset="0"/>
+              </a:rPr>
+              <a:t>(1to1)</a:t>
+            </a:r>
+            <a:endParaRPr lang="en-US" sz="1400" dirty="0">
+              <a:latin typeface="Century Gothic" panose="020B0502020202020204" pitchFamily="34" charset="0"/>
+            </a:endParaRPr>
+          </a:p>
+          <a:p>
+            <a:pPr marL="285750" indent="-285750" rtl="0" fontAlgn="ctr">
+              <a:spcBef>
+                <a:spcPts val="0"/>
+              </a:spcBef>
+              <a:spcAft>
+                <a:spcPts val="0"/>
+              </a:spcAft>
+              <a:buFont typeface="Arial" panose="020B0604020202020204" pitchFamily="34" charset="0"/>
+              <a:buChar char="•"/>
+            </a:pPr>
+            <a:r>
+              <a:rPr lang="en-US" sz="1400" dirty="0">
+                <a:effectLst/>
+                <a:latin typeface="Century Gothic" panose="020B0502020202020204" pitchFamily="34" charset="0"/>
+              </a:rPr>
+              <a:t>Address</a:t>
+            </a:r>
+            <a:endParaRPr lang="en-US" sz="1400" dirty="0">
+              <a:latin typeface="Century Gothic" panose="020B0502020202020204" pitchFamily="34" charset="0"/>
+            </a:endParaRPr>
+          </a:p>
+          <a:p>
+            <a:pPr marL="285750" indent="-285750" rtl="0" fontAlgn="ctr">
+              <a:spcBef>
+                <a:spcPts val="0"/>
+              </a:spcBef>
+              <a:spcAft>
+                <a:spcPts val="0"/>
+              </a:spcAft>
+              <a:buFont typeface="Arial" panose="020B0604020202020204" pitchFamily="34" charset="0"/>
+              <a:buChar char="•"/>
+            </a:pPr>
+            <a:r>
+              <a:rPr lang="en-US" sz="1400" dirty="0">
+                <a:effectLst/>
+                <a:latin typeface="Century Gothic" panose="020B0502020202020204" pitchFamily="34" charset="0"/>
+              </a:rPr>
+              <a:t>City</a:t>
+            </a:r>
+            <a:endParaRPr lang="en-US" sz="1400" dirty="0">
+              <a:latin typeface="Century Gothic" panose="020B0502020202020204" pitchFamily="34" charset="0"/>
+            </a:endParaRPr>
+          </a:p>
+          <a:p>
+            <a:pPr marL="285750" indent="-285750" rtl="0" fontAlgn="ctr">
+              <a:spcBef>
+                <a:spcPts val="0"/>
+              </a:spcBef>
+              <a:spcAft>
+                <a:spcPts val="0"/>
+              </a:spcAft>
+              <a:buFont typeface="Arial" panose="020B0604020202020204" pitchFamily="34" charset="0"/>
+              <a:buChar char="•"/>
+            </a:pPr>
+            <a:r>
+              <a:rPr lang="en-US" sz="1400" dirty="0">
+                <a:effectLst/>
+                <a:latin typeface="Century Gothic" panose="020B0502020202020204" pitchFamily="34" charset="0"/>
+              </a:rPr>
+              <a:t>Country</a:t>
+            </a:r>
+            <a:endParaRPr lang="en-US" sz="1400" dirty="0">
+              <a:latin typeface="Century Gothic" panose="020B0502020202020204" pitchFamily="34" charset="0"/>
+            </a:endParaRPr>
+          </a:p>
+          <a:p>
+            <a:pPr marL="285750" indent="-285750" rtl="0" fontAlgn="ctr">
+              <a:spcBef>
+                <a:spcPts val="0"/>
+              </a:spcBef>
+              <a:spcAft>
+                <a:spcPts val="0"/>
+              </a:spcAft>
+              <a:buFont typeface="Arial" panose="020B0604020202020204" pitchFamily="34" charset="0"/>
+              <a:buChar char="•"/>
+            </a:pPr>
+            <a:r>
+              <a:rPr lang="en-US" sz="1400" dirty="0">
+                <a:effectLst/>
+                <a:latin typeface="Century Gothic" panose="020B0502020202020204" pitchFamily="34" charset="0"/>
+              </a:rPr>
+              <a:t>Phone number</a:t>
+            </a:r>
+          </a:p>
+        </p:txBody>
+      </p:sp>
+      <p:sp>
+        <p:nvSpPr>
+          <p:cNvPr id="7" name="TextBox 6">
+            <a:extLst>
+              <a:ext uri="{FF2B5EF4-FFF2-40B4-BE49-F238E27FC236}">
+                <a16:creationId xmlns:a16="http://schemas.microsoft.com/office/drawing/2014/main" id="{6645AFC8-2B90-1CEC-AF95-C3CC337B94B2}"/>
+              </a:ext>
+            </a:extLst>
+          </p:cNvPr>
+          <p:cNvSpPr txBox="1"/>
+          <p:nvPr/>
+        </p:nvSpPr>
+        <p:spPr>
+          <a:xfrm>
+            <a:off x="343187" y="1258933"/>
             <a:ext cx="2059557" cy="1600438"/>
           </a:xfrm>
           <a:prstGeom prst="rect">
@@ -3369,192 +3554,6 @@
                 <a:effectLst/>
                 <a:latin typeface="Century Gothic" panose="020B0502020202020204" pitchFamily="34" charset="0"/>
               </a:rPr>
-              <a:t>User Profile</a:t>
-            </a:r>
-          </a:p>
-          <a:p>
-            <a:pPr marL="285750" indent="-285750" rtl="0" fontAlgn="ctr">
-              <a:spcBef>
-                <a:spcPts val="0"/>
-              </a:spcBef>
-              <a:spcAft>
-                <a:spcPts val="0"/>
-              </a:spcAft>
-              <a:buFont typeface="Arial" panose="020B0604020202020204" pitchFamily="34" charset="0"/>
-              <a:buChar char="•"/>
-            </a:pPr>
-            <a:r>
-              <a:rPr lang="en-US" sz="1400" dirty="0" err="1">
-                <a:effectLst/>
-                <a:latin typeface="Century Gothic" panose="020B0502020202020204" pitchFamily="34" charset="0"/>
-              </a:rPr>
-              <a:t>User_id</a:t>
-            </a:r>
-            <a:r>
-              <a:rPr lang="en-US" sz="1400" dirty="0">
-                <a:effectLst/>
-                <a:latin typeface="Century Gothic" panose="020B0502020202020204" pitchFamily="34" charset="0"/>
-              </a:rPr>
-              <a:t>(1to1)</a:t>
-            </a:r>
-            <a:endParaRPr lang="en-US" sz="1400" dirty="0">
-              <a:latin typeface="Century Gothic" panose="020B0502020202020204" pitchFamily="34" charset="0"/>
-            </a:endParaRPr>
-          </a:p>
-          <a:p>
-            <a:pPr marL="285750" indent="-285750" rtl="0" fontAlgn="ctr">
-              <a:spcBef>
-                <a:spcPts val="0"/>
-              </a:spcBef>
-              <a:spcAft>
-                <a:spcPts val="0"/>
-              </a:spcAft>
-              <a:buFont typeface="Arial" panose="020B0604020202020204" pitchFamily="34" charset="0"/>
-              <a:buChar char="•"/>
-            </a:pPr>
-            <a:r>
-              <a:rPr lang="en-US" sz="1400" dirty="0">
-                <a:effectLst/>
-                <a:latin typeface="Century Gothic" panose="020B0502020202020204" pitchFamily="34" charset="0"/>
-              </a:rPr>
-              <a:t>Address</a:t>
-            </a:r>
-            <a:endParaRPr lang="en-US" sz="1400" dirty="0">
-              <a:latin typeface="Century Gothic" panose="020B0502020202020204" pitchFamily="34" charset="0"/>
-            </a:endParaRPr>
-          </a:p>
-          <a:p>
-            <a:pPr marL="285750" indent="-285750" rtl="0" fontAlgn="ctr">
-              <a:spcBef>
-                <a:spcPts val="0"/>
-              </a:spcBef>
-              <a:spcAft>
-                <a:spcPts val="0"/>
-              </a:spcAft>
-              <a:buFont typeface="Arial" panose="020B0604020202020204" pitchFamily="34" charset="0"/>
-              <a:buChar char="•"/>
-            </a:pPr>
-            <a:r>
-              <a:rPr lang="en-US" sz="1400" dirty="0">
-                <a:effectLst/>
-                <a:latin typeface="Century Gothic" panose="020B0502020202020204" pitchFamily="34" charset="0"/>
-              </a:rPr>
-              <a:t>City</a:t>
-            </a:r>
-            <a:endParaRPr lang="en-US" sz="1400" dirty="0">
-              <a:latin typeface="Century Gothic" panose="020B0502020202020204" pitchFamily="34" charset="0"/>
-            </a:endParaRPr>
-          </a:p>
-          <a:p>
-            <a:pPr marL="285750" indent="-285750" rtl="0" fontAlgn="ctr">
-              <a:spcBef>
-                <a:spcPts val="0"/>
-              </a:spcBef>
-              <a:spcAft>
-                <a:spcPts val="0"/>
-              </a:spcAft>
-              <a:buFont typeface="Arial" panose="020B0604020202020204" pitchFamily="34" charset="0"/>
-              <a:buChar char="•"/>
-            </a:pPr>
-            <a:r>
-              <a:rPr lang="en-US" sz="1400" dirty="0">
-                <a:effectLst/>
-                <a:latin typeface="Century Gothic" panose="020B0502020202020204" pitchFamily="34" charset="0"/>
-              </a:rPr>
-              <a:t>Country</a:t>
-            </a:r>
-            <a:endParaRPr lang="en-US" sz="1400" dirty="0">
-              <a:latin typeface="Century Gothic" panose="020B0502020202020204" pitchFamily="34" charset="0"/>
-            </a:endParaRPr>
-          </a:p>
-          <a:p>
-            <a:pPr marL="285750" indent="-285750" rtl="0" fontAlgn="ctr">
-              <a:spcBef>
-                <a:spcPts val="0"/>
-              </a:spcBef>
-              <a:spcAft>
-                <a:spcPts val="0"/>
-              </a:spcAft>
-              <a:buFont typeface="Arial" panose="020B0604020202020204" pitchFamily="34" charset="0"/>
-              <a:buChar char="•"/>
-            </a:pPr>
-            <a:r>
-              <a:rPr lang="en-US" sz="1400" dirty="0">
-                <a:effectLst/>
-                <a:latin typeface="Century Gothic" panose="020B0502020202020204" pitchFamily="34" charset="0"/>
-              </a:rPr>
-              <a:t>Phone number</a:t>
-            </a:r>
-          </a:p>
-          <a:p>
-            <a:pPr marL="285750" indent="-285750" rtl="0" fontAlgn="ctr">
-              <a:spcBef>
-                <a:spcPts val="0"/>
-              </a:spcBef>
-              <a:spcAft>
-                <a:spcPts val="0"/>
-              </a:spcAft>
-              <a:buFont typeface="Arial" panose="020B0604020202020204" pitchFamily="34" charset="0"/>
-              <a:buChar char="•"/>
-            </a:pPr>
-            <a:r>
-              <a:rPr lang="en-US" sz="1400" dirty="0">
-                <a:effectLst/>
-                <a:latin typeface="Century Gothic" panose="020B0502020202020204" pitchFamily="34" charset="0"/>
-              </a:rPr>
-              <a:t>Email</a:t>
-            </a:r>
-          </a:p>
-        </p:txBody>
-      </p:sp>
-      <p:sp>
-        <p:nvSpPr>
-          <p:cNvPr id="7" name="TextBox 6">
-            <a:extLst>
-              <a:ext uri="{FF2B5EF4-FFF2-40B4-BE49-F238E27FC236}">
-                <a16:creationId xmlns:a16="http://schemas.microsoft.com/office/drawing/2014/main" id="{6645AFC8-2B90-1CEC-AF95-C3CC337B94B2}"/>
-              </a:ext>
-            </a:extLst>
-          </p:cNvPr>
-          <p:cNvSpPr txBox="1"/>
-          <p:nvPr/>
-        </p:nvSpPr>
-        <p:spPr>
-          <a:xfrm>
-            <a:off x="343187" y="1258933"/>
-            <a:ext cx="2059557" cy="1169551"/>
-          </a:xfrm>
-          <a:prstGeom prst="rect">
-            <a:avLst/>
-          </a:prstGeom>
-          <a:noFill/>
-          <a:ln>
-            <a:solidFill>
-              <a:schemeClr val="accent1">
-                <a:lumMod val="50000"/>
-              </a:schemeClr>
-            </a:solidFill>
-          </a:ln>
-        </p:spPr>
-        <p:txBody>
-          <a:bodyPr wrap="square">
-            <a:spAutoFit/>
-          </a:bodyPr>
-          <a:lstStyle/>
-          <a:p>
-            <a:pPr marL="0" marR="0">
-              <a:spcBef>
-                <a:spcPts val="0"/>
-              </a:spcBef>
-              <a:spcAft>
-                <a:spcPts val="0"/>
-              </a:spcAft>
-            </a:pPr>
-            <a:r>
-              <a:rPr lang="en-US" sz="1400" dirty="0">
-                <a:effectLst/>
-                <a:latin typeface="Century Gothic" panose="020B0502020202020204" pitchFamily="34" charset="0"/>
-              </a:rPr>
               <a:t>Users records</a:t>
             </a:r>
           </a:p>
@@ -3576,9 +3575,42 @@
               </a:rPr>
               <a:t>Id(pk)</a:t>
             </a:r>
-            <a:endParaRPr lang="en-US" sz="1400" dirty="0">
-              <a:latin typeface="Century Gothic" panose="020B0502020202020204" pitchFamily="34" charset="0"/>
-            </a:endParaRPr>
+          </a:p>
+          <a:p>
+            <a:pPr marL="285750" marR="0" indent="-285750">
+              <a:spcBef>
+                <a:spcPts val="0"/>
+              </a:spcBef>
+              <a:spcAft>
+                <a:spcPts val="0"/>
+              </a:spcAft>
+              <a:buFont typeface="Arial" panose="020B0604020202020204" pitchFamily="34" charset="0"/>
+              <a:buChar char="•"/>
+            </a:pPr>
+            <a:r>
+              <a:rPr lang="en-US" sz="1400" dirty="0">
+                <a:latin typeface="Century Gothic" panose="020B0502020202020204" pitchFamily="34" charset="0"/>
+              </a:rPr>
+              <a:t>Username</a:t>
+            </a:r>
+          </a:p>
+          <a:p>
+            <a:pPr marL="285750" marR="0" indent="-285750">
+              <a:spcBef>
+                <a:spcPts val="0"/>
+              </a:spcBef>
+              <a:spcAft>
+                <a:spcPts val="0"/>
+              </a:spcAft>
+              <a:buFont typeface="Arial" panose="020B0604020202020204" pitchFamily="34" charset="0"/>
+              <a:buChar char="•"/>
+            </a:pPr>
+            <a:r>
+              <a:rPr lang="en-US" sz="1400" dirty="0">
+                <a:latin typeface="Century Gothic" panose="020B0502020202020204" pitchFamily="34" charset="0"/>
+              </a:rPr>
+              <a:t>email</a:t>
+            </a:r>
           </a:p>
           <a:p>
             <a:pPr marL="285750" marR="0" indent="-285750">
@@ -3805,7 +3837,7 @@
         <p:spPr>
           <a:xfrm>
             <a:off x="5116135" y="3751988"/>
-            <a:ext cx="1796716" cy="1384995"/>
+            <a:ext cx="1796716" cy="1600438"/>
           </a:xfrm>
           <a:prstGeom prst="rect">
             <a:avLst/>
@@ -3839,6 +3871,25 @@
                 <a:latin typeface="Century Gothic" panose="020B0502020202020204" pitchFamily="34" charset="0"/>
               </a:rPr>
               <a:t>Books</a:t>
+            </a:r>
+          </a:p>
+          <a:p>
+            <a:pPr marL="285750" indent="-285750" rtl="0" fontAlgn="ctr">
+              <a:spcBef>
+                <a:spcPts val="0"/>
+              </a:spcBef>
+              <a:spcAft>
+                <a:spcPts val="0"/>
+              </a:spcAft>
+              <a:buFont typeface="Arial" panose="020B0604020202020204" pitchFamily="34" charset="0"/>
+              <a:buChar char="•"/>
+            </a:pPr>
+            <a:r>
+              <a:rPr lang="en-US" sz="1400" dirty="0">
+                <a:effectLst/>
+                <a:latin typeface="Century Gothic" panose="020B0502020202020204" pitchFamily="34" charset="0"/>
+              </a:rPr>
+              <a:t>id</a:t>
             </a:r>
           </a:p>
           <a:p>
@@ -4233,17 +4284,19 @@
               </a:ext>
             </a:extLst>
           </p:cNvPr>
-          <p:cNvCxnSpPr/>
+          <p:cNvCxnSpPr>
+            <a:cxnSpLocks/>
+          </p:cNvCxnSpPr>
           <p:nvPr/>
         </p:nvCxnSpPr>
         <p:spPr>
           <a:xfrm flipV="1">
-            <a:off x="1300708" y="1501577"/>
-            <a:ext cx="2258921" cy="106790"/>
+            <a:off x="1333358" y="1501577"/>
+            <a:ext cx="2226271" cy="149216"/>
           </a:xfrm>
           <a:prstGeom prst="bentConnector3">
             <a:avLst>
-              <a:gd name="adj1" fmla="val 62650"/>
+              <a:gd name="adj1" fmla="val 50000"/>
             </a:avLst>
           </a:prstGeom>
           <a:ln>
@@ -4274,13 +4327,15 @@
               </a:ext>
             </a:extLst>
           </p:cNvPr>
-          <p:cNvCxnSpPr/>
+          <p:cNvCxnSpPr>
+            <a:cxnSpLocks/>
+          </p:cNvCxnSpPr>
           <p:nvPr/>
         </p:nvCxnSpPr>
         <p:spPr>
           <a:xfrm>
             <a:off x="1372965" y="4106638"/>
-            <a:ext cx="3852178" cy="457200"/>
+            <a:ext cx="3811356" cy="626899"/>
           </a:xfrm>
           <a:prstGeom prst="bentConnector3">
             <a:avLst/>
@@ -4313,13 +4368,15 @@
               </a:ext>
             </a:extLst>
           </p:cNvPr>
-          <p:cNvCxnSpPr/>
+          <p:cNvCxnSpPr>
+            <a:cxnSpLocks/>
+          </p:cNvCxnSpPr>
           <p:nvPr/>
         </p:nvCxnSpPr>
         <p:spPr>
           <a:xfrm flipV="1">
-            <a:off x="2228850" y="4988381"/>
-            <a:ext cx="2955471" cy="1357180"/>
+            <a:off x="2228850" y="5136984"/>
+            <a:ext cx="2887285" cy="1208577"/>
           </a:xfrm>
           <a:prstGeom prst="bentConnector3">
             <a:avLst/>
@@ -4504,8 +4561,8 @@
         </p:nvCxnSpPr>
         <p:spPr>
           <a:xfrm rot="16200000" flipH="1">
-            <a:off x="4293479" y="-492029"/>
-            <a:ext cx="959696" cy="6800722"/>
+            <a:off x="4508923" y="-276586"/>
+            <a:ext cx="528809" cy="6800722"/>
           </a:xfrm>
           <a:prstGeom prst="bentConnector2">
             <a:avLst/>
@@ -4547,7 +4604,7 @@
         <p:spPr>
           <a:xfrm flipV="1">
             <a:off x="6912851" y="3603444"/>
-            <a:ext cx="1260838" cy="841042"/>
+            <a:ext cx="1260838" cy="948763"/>
           </a:xfrm>
           <a:prstGeom prst="bentConnector3">
             <a:avLst/>
@@ -4606,6 +4663,406 @@
               </a:rPr>
               <a:t>LIBRARY MANAGEMENT SYSTEM DESIGN</a:t>
             </a:r>
+          </a:p>
+        </p:txBody>
+      </p:sp>
+      <p:sp>
+        <p:nvSpPr>
+          <p:cNvPr id="2" name="TextBox 1">
+            <a:extLst>
+              <a:ext uri="{FF2B5EF4-FFF2-40B4-BE49-F238E27FC236}">
+                <a16:creationId xmlns:a16="http://schemas.microsoft.com/office/drawing/2014/main" id="{6BFEC28D-984D-0677-A2FA-3559605744F3}"/>
+              </a:ext>
+            </a:extLst>
+          </p:cNvPr>
+          <p:cNvSpPr txBox="1"/>
+          <p:nvPr/>
+        </p:nvSpPr>
+        <p:spPr>
+          <a:xfrm>
+            <a:off x="2938244" y="3818887"/>
+            <a:ext cx="243462" cy="369332"/>
+          </a:xfrm>
+          <a:prstGeom prst="rect">
+            <a:avLst/>
+          </a:prstGeom>
+          <a:noFill/>
+        </p:spPr>
+        <p:txBody>
+          <a:bodyPr wrap="square" rtlCol="0">
+            <a:spAutoFit/>
+          </a:bodyPr>
+          <a:lstStyle/>
+          <a:p>
+            <a:r>
+              <a:rPr lang="en-US" dirty="0"/>
+              <a:t>1</a:t>
+            </a:r>
+          </a:p>
+        </p:txBody>
+      </p:sp>
+      <p:sp>
+        <p:nvSpPr>
+          <p:cNvPr id="3" name="TextBox 2">
+            <a:extLst>
+              <a:ext uri="{FF2B5EF4-FFF2-40B4-BE49-F238E27FC236}">
+                <a16:creationId xmlns:a16="http://schemas.microsoft.com/office/drawing/2014/main" id="{800088B5-31E5-63D7-E572-F5404DD17797}"/>
+              </a:ext>
+            </a:extLst>
+          </p:cNvPr>
+          <p:cNvSpPr txBox="1"/>
+          <p:nvPr/>
+        </p:nvSpPr>
+        <p:spPr>
+          <a:xfrm>
+            <a:off x="4827133" y="4408139"/>
+            <a:ext cx="243462" cy="369332"/>
+          </a:xfrm>
+          <a:prstGeom prst="rect">
+            <a:avLst/>
+          </a:prstGeom>
+          <a:noFill/>
+        </p:spPr>
+        <p:txBody>
+          <a:bodyPr wrap="square" rtlCol="0">
+            <a:spAutoFit/>
+          </a:bodyPr>
+          <a:lstStyle/>
+          <a:p>
+            <a:r>
+              <a:rPr lang="en-US" dirty="0"/>
+              <a:t>M</a:t>
+            </a:r>
+          </a:p>
+        </p:txBody>
+      </p:sp>
+      <p:sp>
+        <p:nvSpPr>
+          <p:cNvPr id="4" name="TextBox 3">
+            <a:extLst>
+              <a:ext uri="{FF2B5EF4-FFF2-40B4-BE49-F238E27FC236}">
+                <a16:creationId xmlns:a16="http://schemas.microsoft.com/office/drawing/2014/main" id="{16A89A4B-97C0-2872-B6A3-35A1BDC8C5FA}"/>
+              </a:ext>
+            </a:extLst>
+          </p:cNvPr>
+          <p:cNvSpPr txBox="1"/>
+          <p:nvPr/>
+        </p:nvSpPr>
+        <p:spPr>
+          <a:xfrm>
+            <a:off x="4827133" y="5136984"/>
+            <a:ext cx="243462" cy="369332"/>
+          </a:xfrm>
+          <a:prstGeom prst="rect">
+            <a:avLst/>
+          </a:prstGeom>
+          <a:noFill/>
+        </p:spPr>
+        <p:txBody>
+          <a:bodyPr wrap="square" rtlCol="0">
+            <a:spAutoFit/>
+          </a:bodyPr>
+          <a:lstStyle/>
+          <a:p>
+            <a:r>
+              <a:rPr lang="en-US" dirty="0"/>
+              <a:t>M</a:t>
+            </a:r>
+          </a:p>
+        </p:txBody>
+      </p:sp>
+      <p:sp>
+        <p:nvSpPr>
+          <p:cNvPr id="5" name="TextBox 4">
+            <a:extLst>
+              <a:ext uri="{FF2B5EF4-FFF2-40B4-BE49-F238E27FC236}">
+                <a16:creationId xmlns:a16="http://schemas.microsoft.com/office/drawing/2014/main" id="{EC057EA5-DFFD-3A7C-4D9A-04425A118057}"/>
+              </a:ext>
+            </a:extLst>
+          </p:cNvPr>
+          <p:cNvSpPr txBox="1"/>
+          <p:nvPr/>
+        </p:nvSpPr>
+        <p:spPr>
+          <a:xfrm>
+            <a:off x="2694782" y="5976229"/>
+            <a:ext cx="243462" cy="369332"/>
+          </a:xfrm>
+          <a:prstGeom prst="rect">
+            <a:avLst/>
+          </a:prstGeom>
+          <a:noFill/>
+        </p:spPr>
+        <p:txBody>
+          <a:bodyPr wrap="square" rtlCol="0">
+            <a:spAutoFit/>
+          </a:bodyPr>
+          <a:lstStyle/>
+          <a:p>
+            <a:r>
+              <a:rPr lang="en-US" dirty="0"/>
+              <a:t>M</a:t>
+            </a:r>
+          </a:p>
+        </p:txBody>
+      </p:sp>
+      <p:sp>
+        <p:nvSpPr>
+          <p:cNvPr id="12" name="TextBox 11">
+            <a:extLst>
+              <a:ext uri="{FF2B5EF4-FFF2-40B4-BE49-F238E27FC236}">
+                <a16:creationId xmlns:a16="http://schemas.microsoft.com/office/drawing/2014/main" id="{4DE6E148-7EC5-368F-304B-23EC1B5230A1}"/>
+              </a:ext>
+            </a:extLst>
+          </p:cNvPr>
+          <p:cNvSpPr txBox="1"/>
+          <p:nvPr/>
+        </p:nvSpPr>
+        <p:spPr>
+          <a:xfrm>
+            <a:off x="2116482" y="1648031"/>
+            <a:ext cx="243462" cy="369332"/>
+          </a:xfrm>
+          <a:prstGeom prst="rect">
+            <a:avLst/>
+          </a:prstGeom>
+          <a:noFill/>
+        </p:spPr>
+        <p:txBody>
+          <a:bodyPr wrap="square" rtlCol="0">
+            <a:spAutoFit/>
+          </a:bodyPr>
+          <a:lstStyle/>
+          <a:p>
+            <a:r>
+              <a:rPr lang="en-US" dirty="0"/>
+              <a:t>1</a:t>
+            </a:r>
+          </a:p>
+        </p:txBody>
+      </p:sp>
+      <p:sp>
+        <p:nvSpPr>
+          <p:cNvPr id="14" name="TextBox 13">
+            <a:extLst>
+              <a:ext uri="{FF2B5EF4-FFF2-40B4-BE49-F238E27FC236}">
+                <a16:creationId xmlns:a16="http://schemas.microsoft.com/office/drawing/2014/main" id="{C12EB584-1CE1-D7A0-ED39-5FD25DB4CD0C}"/>
+              </a:ext>
+            </a:extLst>
+          </p:cNvPr>
+          <p:cNvSpPr txBox="1"/>
+          <p:nvPr/>
+        </p:nvSpPr>
+        <p:spPr>
+          <a:xfrm>
+            <a:off x="3278727" y="1088311"/>
+            <a:ext cx="243462" cy="369332"/>
+          </a:xfrm>
+          <a:prstGeom prst="rect">
+            <a:avLst/>
+          </a:prstGeom>
+          <a:noFill/>
+        </p:spPr>
+        <p:txBody>
+          <a:bodyPr wrap="square" rtlCol="0">
+            <a:spAutoFit/>
+          </a:bodyPr>
+          <a:lstStyle/>
+          <a:p>
+            <a:r>
+              <a:rPr lang="en-US" dirty="0"/>
+              <a:t>1</a:t>
+            </a:r>
+          </a:p>
+        </p:txBody>
+      </p:sp>
+      <p:sp>
+        <p:nvSpPr>
+          <p:cNvPr id="16" name="TextBox 15">
+            <a:extLst>
+              <a:ext uri="{FF2B5EF4-FFF2-40B4-BE49-F238E27FC236}">
+                <a16:creationId xmlns:a16="http://schemas.microsoft.com/office/drawing/2014/main" id="{F89EB10F-9D82-2C95-EE54-6EBD434917AA}"/>
+              </a:ext>
+            </a:extLst>
+          </p:cNvPr>
+          <p:cNvSpPr txBox="1"/>
+          <p:nvPr/>
+        </p:nvSpPr>
+        <p:spPr>
+          <a:xfrm>
+            <a:off x="1377729" y="2834183"/>
+            <a:ext cx="243462" cy="369332"/>
+          </a:xfrm>
+          <a:prstGeom prst="rect">
+            <a:avLst/>
+          </a:prstGeom>
+          <a:noFill/>
+        </p:spPr>
+        <p:txBody>
+          <a:bodyPr wrap="square" rtlCol="0">
+            <a:spAutoFit/>
+          </a:bodyPr>
+          <a:lstStyle/>
+          <a:p>
+            <a:r>
+              <a:rPr lang="en-US" dirty="0"/>
+              <a:t>1</a:t>
+            </a:r>
+          </a:p>
+        </p:txBody>
+      </p:sp>
+      <p:sp>
+        <p:nvSpPr>
+          <p:cNvPr id="18" name="TextBox 17">
+            <a:extLst>
+              <a:ext uri="{FF2B5EF4-FFF2-40B4-BE49-F238E27FC236}">
+                <a16:creationId xmlns:a16="http://schemas.microsoft.com/office/drawing/2014/main" id="{41279F11-1BB4-BC45-D28A-6EC03434E89B}"/>
+              </a:ext>
+            </a:extLst>
+          </p:cNvPr>
+          <p:cNvSpPr txBox="1"/>
+          <p:nvPr/>
+        </p:nvSpPr>
+        <p:spPr>
+          <a:xfrm>
+            <a:off x="7831590" y="3054712"/>
+            <a:ext cx="243462" cy="369332"/>
+          </a:xfrm>
+          <a:prstGeom prst="rect">
+            <a:avLst/>
+          </a:prstGeom>
+          <a:noFill/>
+        </p:spPr>
+        <p:txBody>
+          <a:bodyPr wrap="square" rtlCol="0">
+            <a:spAutoFit/>
+          </a:bodyPr>
+          <a:lstStyle/>
+          <a:p>
+            <a:r>
+              <a:rPr lang="en-US" dirty="0"/>
+              <a:t>M</a:t>
+            </a:r>
+          </a:p>
+        </p:txBody>
+      </p:sp>
+      <p:sp>
+        <p:nvSpPr>
+          <p:cNvPr id="20" name="TextBox 19">
+            <a:extLst>
+              <a:ext uri="{FF2B5EF4-FFF2-40B4-BE49-F238E27FC236}">
+                <a16:creationId xmlns:a16="http://schemas.microsoft.com/office/drawing/2014/main" id="{708AB1FC-E3D4-01CC-B6BD-4D60A5052044}"/>
+              </a:ext>
+            </a:extLst>
+          </p:cNvPr>
+          <p:cNvSpPr txBox="1"/>
+          <p:nvPr/>
+        </p:nvSpPr>
+        <p:spPr>
+          <a:xfrm>
+            <a:off x="7875117" y="3585237"/>
+            <a:ext cx="243462" cy="369332"/>
+          </a:xfrm>
+          <a:prstGeom prst="rect">
+            <a:avLst/>
+          </a:prstGeom>
+          <a:noFill/>
+        </p:spPr>
+        <p:txBody>
+          <a:bodyPr wrap="square" rtlCol="0">
+            <a:spAutoFit/>
+          </a:bodyPr>
+          <a:lstStyle/>
+          <a:p>
+            <a:r>
+              <a:rPr lang="en-US" dirty="0"/>
+              <a:t>M</a:t>
+            </a:r>
+          </a:p>
+        </p:txBody>
+      </p:sp>
+      <p:sp>
+        <p:nvSpPr>
+          <p:cNvPr id="22" name="TextBox 21">
+            <a:extLst>
+              <a:ext uri="{FF2B5EF4-FFF2-40B4-BE49-F238E27FC236}">
+                <a16:creationId xmlns:a16="http://schemas.microsoft.com/office/drawing/2014/main" id="{8EDEBD52-9320-67B9-D11E-7F19E0736000}"/>
+              </a:ext>
+            </a:extLst>
+          </p:cNvPr>
+          <p:cNvSpPr txBox="1"/>
+          <p:nvPr/>
+        </p:nvSpPr>
+        <p:spPr>
+          <a:xfrm>
+            <a:off x="6912851" y="4552207"/>
+            <a:ext cx="565635" cy="369332"/>
+          </a:xfrm>
+          <a:prstGeom prst="rect">
+            <a:avLst/>
+          </a:prstGeom>
+          <a:noFill/>
+        </p:spPr>
+        <p:txBody>
+          <a:bodyPr wrap="square" rtlCol="0">
+            <a:spAutoFit/>
+          </a:bodyPr>
+          <a:lstStyle/>
+          <a:p>
+            <a:r>
+              <a:rPr lang="en-US" dirty="0"/>
+              <a:t>1/M</a:t>
+            </a:r>
+          </a:p>
+        </p:txBody>
+      </p:sp>
+      <p:sp>
+        <p:nvSpPr>
+          <p:cNvPr id="24" name="Rectangle 23">
+            <a:extLst>
+              <a:ext uri="{FF2B5EF4-FFF2-40B4-BE49-F238E27FC236}">
+                <a16:creationId xmlns:a16="http://schemas.microsoft.com/office/drawing/2014/main" id="{5618BCAD-DADB-904F-7DC7-0C6FA5FA0303}"/>
+              </a:ext>
+            </a:extLst>
+          </p:cNvPr>
+          <p:cNvSpPr/>
+          <p:nvPr/>
+        </p:nvSpPr>
+        <p:spPr>
+          <a:xfrm>
+            <a:off x="343187" y="3585237"/>
+            <a:ext cx="7331242" cy="3215613"/>
+          </a:xfrm>
+          <a:prstGeom prst="rect">
+            <a:avLst/>
+          </a:prstGeom>
+          <a:noFill/>
+          <a:ln w="12700">
+            <a:prstDash val="dash"/>
+          </a:ln>
+        </p:spPr>
+        <p:style>
+          <a:lnRef idx="2">
+            <a:schemeClr val="accent1">
+              <a:shade val="15000"/>
+            </a:schemeClr>
+          </a:lnRef>
+          <a:fillRef idx="1">
+            <a:schemeClr val="accent1"/>
+          </a:fillRef>
+          <a:effectRef idx="0">
+            <a:schemeClr val="accent1"/>
+          </a:effectRef>
+          <a:fontRef idx="minor">
+            <a:schemeClr val="lt1"/>
+          </a:fontRef>
+        </p:style>
+        <p:txBody>
+          <a:bodyPr rtlCol="0" anchor="ctr"/>
+          <a:lstStyle/>
+          <a:p>
+            <a:pPr algn="ctr"/>
+            <a:endParaRPr lang="en-US"/>
           </a:p>
         </p:txBody>
       </p:sp>

</xml_diff>

<commit_message>
added book request feature anda frontend
</commit_message>
<xml_diff>
--- a/LMS backend design.pptx
+++ b/LMS backend design.pptx
@@ -6,6 +6,7 @@
   </p:sldMasterIdLst>
   <p:sldIdLst>
     <p:sldId id="256" r:id="rId2"/>
+    <p:sldId id="257" r:id="rId3"/>
   </p:sldIdLst>
   <p:sldSz cx="12192000" cy="6858000"/>
   <p:notesSz cx="6858000" cy="9144000"/>
@@ -259,7 +260,7 @@
           <a:p>
             <a:fld id="{5CBA09D6-ECFC-4D5D-996A-E59E4A8C3E3B}" type="datetimeFigureOut">
               <a:rPr lang="en-US" smtClean="0"/>
-              <a:t>9/28/2026</a:t>
+              <a:t>10/7/2026</a:t>
             </a:fld>
             <a:endParaRPr lang="en-US"/>
           </a:p>
@@ -457,7 +458,7 @@
           <a:p>
             <a:fld id="{5CBA09D6-ECFC-4D5D-996A-E59E4A8C3E3B}" type="datetimeFigureOut">
               <a:rPr lang="en-US" smtClean="0"/>
-              <a:t>9/28/2026</a:t>
+              <a:t>10/7/2026</a:t>
             </a:fld>
             <a:endParaRPr lang="en-US"/>
           </a:p>
@@ -665,7 +666,7 @@
           <a:p>
             <a:fld id="{5CBA09D6-ECFC-4D5D-996A-E59E4A8C3E3B}" type="datetimeFigureOut">
               <a:rPr lang="en-US" smtClean="0"/>
-              <a:t>9/28/2026</a:t>
+              <a:t>10/7/2026</a:t>
             </a:fld>
             <a:endParaRPr lang="en-US"/>
           </a:p>
@@ -863,7 +864,7 @@
           <a:p>
             <a:fld id="{5CBA09D6-ECFC-4D5D-996A-E59E4A8C3E3B}" type="datetimeFigureOut">
               <a:rPr lang="en-US" smtClean="0"/>
-              <a:t>9/28/2026</a:t>
+              <a:t>10/7/2026</a:t>
             </a:fld>
             <a:endParaRPr lang="en-US"/>
           </a:p>
@@ -1138,7 +1139,7 @@
           <a:p>
             <a:fld id="{5CBA09D6-ECFC-4D5D-996A-E59E4A8C3E3B}" type="datetimeFigureOut">
               <a:rPr lang="en-US" smtClean="0"/>
-              <a:t>9/28/2026</a:t>
+              <a:t>10/7/2026</a:t>
             </a:fld>
             <a:endParaRPr lang="en-US"/>
           </a:p>
@@ -1403,7 +1404,7 @@
           <a:p>
             <a:fld id="{5CBA09D6-ECFC-4D5D-996A-E59E4A8C3E3B}" type="datetimeFigureOut">
               <a:rPr lang="en-US" smtClean="0"/>
-              <a:t>9/28/2026</a:t>
+              <a:t>10/7/2026</a:t>
             </a:fld>
             <a:endParaRPr lang="en-US"/>
           </a:p>
@@ -1815,7 +1816,7 @@
           <a:p>
             <a:fld id="{5CBA09D6-ECFC-4D5D-996A-E59E4A8C3E3B}" type="datetimeFigureOut">
               <a:rPr lang="en-US" smtClean="0"/>
-              <a:t>9/28/2026</a:t>
+              <a:t>10/7/2026</a:t>
             </a:fld>
             <a:endParaRPr lang="en-US"/>
           </a:p>
@@ -1956,7 +1957,7 @@
           <a:p>
             <a:fld id="{5CBA09D6-ECFC-4D5D-996A-E59E4A8C3E3B}" type="datetimeFigureOut">
               <a:rPr lang="en-US" smtClean="0"/>
-              <a:t>9/28/2026</a:t>
+              <a:t>10/7/2026</a:t>
             </a:fld>
             <a:endParaRPr lang="en-US"/>
           </a:p>
@@ -2069,7 +2070,7 @@
           <a:p>
             <a:fld id="{5CBA09D6-ECFC-4D5D-996A-E59E4A8C3E3B}" type="datetimeFigureOut">
               <a:rPr lang="en-US" smtClean="0"/>
-              <a:t>9/28/2026</a:t>
+              <a:t>10/7/2026</a:t>
             </a:fld>
             <a:endParaRPr lang="en-US"/>
           </a:p>
@@ -2380,7 +2381,7 @@
           <a:p>
             <a:fld id="{5CBA09D6-ECFC-4D5D-996A-E59E4A8C3E3B}" type="datetimeFigureOut">
               <a:rPr lang="en-US" smtClean="0"/>
-              <a:t>9/28/2026</a:t>
+              <a:t>10/7/2026</a:t>
             </a:fld>
             <a:endParaRPr lang="en-US"/>
           </a:p>
@@ -2668,7 +2669,7 @@
           <a:p>
             <a:fld id="{5CBA09D6-ECFC-4D5D-996A-E59E4A8C3E3B}" type="datetimeFigureOut">
               <a:rPr lang="en-US" smtClean="0"/>
-              <a:t>9/28/2026</a:t>
+              <a:t>10/7/2026</a:t>
             </a:fld>
             <a:endParaRPr lang="en-US"/>
           </a:p>
@@ -2909,7 +2910,7 @@
           <a:p>
             <a:fld id="{5CBA09D6-ECFC-4D5D-996A-E59E4A8C3E3B}" type="datetimeFigureOut">
               <a:rPr lang="en-US" smtClean="0"/>
-              <a:t>9/28/2026</a:t>
+              <a:t>10/7/2026</a:t>
             </a:fld>
             <a:endParaRPr lang="en-US"/>
           </a:p>
@@ -5070,6 +5071,2095 @@
     <p:extLst>
       <p:ext uri="{BB962C8B-B14F-4D97-AF65-F5344CB8AC3E}">
         <p14:creationId xmlns:p14="http://schemas.microsoft.com/office/powerpoint/2010/main" val="1794632832"/>
+      </p:ext>
+    </p:extLst>
+  </p:cSld>
+  <p:clrMapOvr>
+    <a:masterClrMapping/>
+  </p:clrMapOvr>
+</p:sld>
+</file>
+
+<file path=ppt/slides/slide2.xml><?xml version="1.0" encoding="utf-8"?>
+<p:sld xmlns:a="http://schemas.openxmlformats.org/drawingml/2006/main" xmlns:r="http://schemas.openxmlformats.org/officeDocument/2006/relationships" xmlns:p="http://schemas.openxmlformats.org/presentationml/2006/main">
+  <p:cSld>
+    <p:spTree>
+      <p:nvGrpSpPr>
+        <p:cNvPr id="1" name=""/>
+        <p:cNvGrpSpPr/>
+        <p:nvPr/>
+      </p:nvGrpSpPr>
+      <p:grpSpPr>
+        <a:xfrm>
+          <a:off x="0" y="0"/>
+          <a:ext cx="0" cy="0"/>
+          <a:chOff x="0" y="0"/>
+          <a:chExt cx="0" cy="0"/>
+        </a:xfrm>
+      </p:grpSpPr>
+      <p:sp>
+        <p:nvSpPr>
+          <p:cNvPr id="9" name="TextBox 8">
+            <a:extLst>
+              <a:ext uri="{FF2B5EF4-FFF2-40B4-BE49-F238E27FC236}">
+                <a16:creationId xmlns:a16="http://schemas.microsoft.com/office/drawing/2014/main" id="{0BC97872-7FBC-5B0F-0EB3-5B85099A8FFA}"/>
+              </a:ext>
+            </a:extLst>
+          </p:cNvPr>
+          <p:cNvSpPr txBox="1"/>
+          <p:nvPr/>
+        </p:nvSpPr>
+        <p:spPr>
+          <a:xfrm>
+            <a:off x="4611309" y="1369909"/>
+            <a:ext cx="2158041" cy="1384995"/>
+          </a:xfrm>
+          <a:prstGeom prst="rect">
+            <a:avLst/>
+          </a:prstGeom>
+          <a:noFill/>
+          <a:ln>
+            <a:solidFill>
+              <a:schemeClr val="accent1">
+                <a:lumMod val="50000"/>
+              </a:schemeClr>
+            </a:solidFill>
+          </a:ln>
+        </p:spPr>
+        <p:txBody>
+          <a:bodyPr wrap="square">
+            <a:spAutoFit/>
+          </a:bodyPr>
+          <a:lstStyle/>
+          <a:p>
+            <a:pPr marL="0" marR="0">
+              <a:spcBef>
+                <a:spcPts val="0"/>
+              </a:spcBef>
+              <a:spcAft>
+                <a:spcPts val="0"/>
+              </a:spcAft>
+            </a:pPr>
+            <a:r>
+              <a:rPr lang="en-US" sz="1400" dirty="0">
+                <a:effectLst/>
+                <a:latin typeface="Century Gothic" panose="020B0502020202020204" pitchFamily="34" charset="0"/>
+              </a:rPr>
+              <a:t>Author</a:t>
+            </a:r>
+          </a:p>
+          <a:p>
+            <a:pPr marL="285750" indent="-285750" rtl="0" fontAlgn="ctr">
+              <a:spcBef>
+                <a:spcPts val="0"/>
+              </a:spcBef>
+              <a:spcAft>
+                <a:spcPts val="0"/>
+              </a:spcAft>
+              <a:buFont typeface="Arial" panose="020B0604020202020204" pitchFamily="34" charset="0"/>
+              <a:buChar char="•"/>
+            </a:pPr>
+            <a:r>
+              <a:rPr lang="en-US" sz="1400" dirty="0">
+                <a:effectLst/>
+                <a:latin typeface="Century Gothic" panose="020B0502020202020204" pitchFamily="34" charset="0"/>
+              </a:rPr>
+              <a:t>Id</a:t>
+            </a:r>
+          </a:p>
+          <a:p>
+            <a:pPr marL="285750" indent="-285750" rtl="0" fontAlgn="ctr">
+              <a:spcBef>
+                <a:spcPts val="0"/>
+              </a:spcBef>
+              <a:spcAft>
+                <a:spcPts val="0"/>
+              </a:spcAft>
+              <a:buFont typeface="Arial" panose="020B0604020202020204" pitchFamily="34" charset="0"/>
+              <a:buChar char="•"/>
+            </a:pPr>
+            <a:r>
+              <a:rPr lang="en-US" sz="1400" dirty="0">
+                <a:effectLst/>
+                <a:latin typeface="Century Gothic" panose="020B0502020202020204" pitchFamily="34" charset="0"/>
+              </a:rPr>
+              <a:t>First Name</a:t>
+            </a:r>
+          </a:p>
+          <a:p>
+            <a:pPr marL="285750" indent="-285750" rtl="0" fontAlgn="ctr">
+              <a:spcBef>
+                <a:spcPts val="0"/>
+              </a:spcBef>
+              <a:spcAft>
+                <a:spcPts val="0"/>
+              </a:spcAft>
+              <a:buFont typeface="Arial" panose="020B0604020202020204" pitchFamily="34" charset="0"/>
+              <a:buChar char="•"/>
+            </a:pPr>
+            <a:r>
+              <a:rPr lang="en-US" sz="1400" dirty="0">
+                <a:effectLst/>
+                <a:latin typeface="Century Gothic" panose="020B0502020202020204" pitchFamily="34" charset="0"/>
+              </a:rPr>
+              <a:t>Last name</a:t>
+            </a:r>
+          </a:p>
+          <a:p>
+            <a:pPr marL="285750" indent="-285750" rtl="0" fontAlgn="ctr">
+              <a:spcBef>
+                <a:spcPts val="0"/>
+              </a:spcBef>
+              <a:spcAft>
+                <a:spcPts val="0"/>
+              </a:spcAft>
+              <a:buFont typeface="Arial" panose="020B0604020202020204" pitchFamily="34" charset="0"/>
+              <a:buChar char="•"/>
+            </a:pPr>
+            <a:r>
+              <a:rPr lang="en-US" sz="1400" dirty="0">
+                <a:effectLst/>
+                <a:latin typeface="Century Gothic" panose="020B0502020202020204" pitchFamily="34" charset="0"/>
+              </a:rPr>
+              <a:t>DOB</a:t>
+            </a:r>
+            <a:endParaRPr lang="en-US" sz="1400" dirty="0">
+              <a:latin typeface="Century Gothic" panose="020B0502020202020204" pitchFamily="34" charset="0"/>
+            </a:endParaRPr>
+          </a:p>
+          <a:p>
+            <a:pPr marL="285750" indent="-285750" rtl="0" fontAlgn="ctr">
+              <a:spcBef>
+                <a:spcPts val="0"/>
+              </a:spcBef>
+              <a:spcAft>
+                <a:spcPts val="0"/>
+              </a:spcAft>
+              <a:buFont typeface="Arial" panose="020B0604020202020204" pitchFamily="34" charset="0"/>
+              <a:buChar char="•"/>
+            </a:pPr>
+            <a:r>
+              <a:rPr lang="en-US" sz="1400" dirty="0">
+                <a:effectLst/>
+                <a:latin typeface="Century Gothic" panose="020B0502020202020204" pitchFamily="34" charset="0"/>
+              </a:rPr>
+              <a:t>Year of Death</a:t>
+            </a:r>
+          </a:p>
+        </p:txBody>
+      </p:sp>
+      <p:sp>
+        <p:nvSpPr>
+          <p:cNvPr id="13" name="TextBox 12">
+            <a:extLst>
+              <a:ext uri="{FF2B5EF4-FFF2-40B4-BE49-F238E27FC236}">
+                <a16:creationId xmlns:a16="http://schemas.microsoft.com/office/drawing/2014/main" id="{433D122F-494D-B787-C6E4-7CCA4D57C59F}"/>
+              </a:ext>
+            </a:extLst>
+          </p:cNvPr>
+          <p:cNvSpPr txBox="1"/>
+          <p:nvPr/>
+        </p:nvSpPr>
+        <p:spPr>
+          <a:xfrm>
+            <a:off x="264978" y="1278811"/>
+            <a:ext cx="1796716" cy="1600438"/>
+          </a:xfrm>
+          <a:prstGeom prst="rect">
+            <a:avLst/>
+          </a:prstGeom>
+          <a:noFill/>
+          <a:ln>
+            <a:solidFill>
+              <a:schemeClr val="accent1">
+                <a:lumMod val="50000"/>
+              </a:schemeClr>
+            </a:solidFill>
+          </a:ln>
+        </p:spPr>
+        <p:txBody>
+          <a:bodyPr wrap="square">
+            <a:spAutoFit/>
+          </a:bodyPr>
+          <a:lstStyle/>
+          <a:p>
+            <a:pPr marL="0" marR="0">
+              <a:spcBef>
+                <a:spcPts val="0"/>
+              </a:spcBef>
+              <a:spcAft>
+                <a:spcPts val="0"/>
+              </a:spcAft>
+            </a:pPr>
+            <a:r>
+              <a:rPr lang="en-US" sz="1400" dirty="0">
+                <a:effectLst/>
+                <a:latin typeface="Century Gothic" panose="020B0502020202020204" pitchFamily="34" charset="0"/>
+              </a:rPr>
+              <a:t>Books</a:t>
+            </a:r>
+          </a:p>
+          <a:p>
+            <a:pPr marL="285750" indent="-285750" rtl="0" fontAlgn="ctr">
+              <a:spcBef>
+                <a:spcPts val="0"/>
+              </a:spcBef>
+              <a:spcAft>
+                <a:spcPts val="0"/>
+              </a:spcAft>
+              <a:buFont typeface="Arial" panose="020B0604020202020204" pitchFamily="34" charset="0"/>
+              <a:buChar char="•"/>
+            </a:pPr>
+            <a:r>
+              <a:rPr lang="en-US" sz="1400" dirty="0">
+                <a:effectLst/>
+                <a:latin typeface="Century Gothic" panose="020B0502020202020204" pitchFamily="34" charset="0"/>
+              </a:rPr>
+              <a:t>id</a:t>
+            </a:r>
+          </a:p>
+          <a:p>
+            <a:pPr marL="285750" indent="-285750" rtl="0" fontAlgn="ctr">
+              <a:spcBef>
+                <a:spcPts val="0"/>
+              </a:spcBef>
+              <a:spcAft>
+                <a:spcPts val="0"/>
+              </a:spcAft>
+              <a:buFont typeface="Arial" panose="020B0604020202020204" pitchFamily="34" charset="0"/>
+              <a:buChar char="•"/>
+            </a:pPr>
+            <a:r>
+              <a:rPr lang="en-US" sz="1400" dirty="0">
+                <a:effectLst/>
+                <a:latin typeface="Century Gothic" panose="020B0502020202020204" pitchFamily="34" charset="0"/>
+              </a:rPr>
+              <a:t>Title</a:t>
+            </a:r>
+          </a:p>
+          <a:p>
+            <a:pPr marL="285750" indent="-285750" rtl="0" fontAlgn="ctr">
+              <a:spcBef>
+                <a:spcPts val="0"/>
+              </a:spcBef>
+              <a:spcAft>
+                <a:spcPts val="0"/>
+              </a:spcAft>
+              <a:buFont typeface="Arial" panose="020B0604020202020204" pitchFamily="34" charset="0"/>
+              <a:buChar char="•"/>
+            </a:pPr>
+            <a:r>
+              <a:rPr lang="en-US" sz="1400" dirty="0">
+                <a:effectLst/>
+                <a:latin typeface="Century Gothic" panose="020B0502020202020204" pitchFamily="34" charset="0"/>
+              </a:rPr>
+              <a:t>Isbn</a:t>
+            </a:r>
+            <a:endParaRPr lang="en-US" sz="1400" dirty="0">
+              <a:latin typeface="Century Gothic" panose="020B0502020202020204" pitchFamily="34" charset="0"/>
+            </a:endParaRPr>
+          </a:p>
+          <a:p>
+            <a:pPr marL="285750" indent="-285750" rtl="0" fontAlgn="ctr">
+              <a:spcBef>
+                <a:spcPts val="0"/>
+              </a:spcBef>
+              <a:spcAft>
+                <a:spcPts val="0"/>
+              </a:spcAft>
+              <a:buFont typeface="Arial" panose="020B0604020202020204" pitchFamily="34" charset="0"/>
+              <a:buChar char="•"/>
+            </a:pPr>
+            <a:r>
+              <a:rPr lang="en-US" sz="1400" dirty="0">
+                <a:effectLst/>
+                <a:latin typeface="Century Gothic" panose="020B0502020202020204" pitchFamily="34" charset="0"/>
+              </a:rPr>
+              <a:t>Author (FK)</a:t>
+            </a:r>
+          </a:p>
+          <a:p>
+            <a:pPr marL="285750" indent="-285750" rtl="0" fontAlgn="ctr">
+              <a:spcBef>
+                <a:spcPts val="0"/>
+              </a:spcBef>
+              <a:spcAft>
+                <a:spcPts val="0"/>
+              </a:spcAft>
+              <a:buFont typeface="Arial" panose="020B0604020202020204" pitchFamily="34" charset="0"/>
+              <a:buChar char="•"/>
+            </a:pPr>
+            <a:r>
+              <a:rPr lang="en-US" sz="1400" dirty="0">
+                <a:effectLst/>
+                <a:latin typeface="Century Gothic" panose="020B0502020202020204" pitchFamily="34" charset="0"/>
+              </a:rPr>
+              <a:t>Published date</a:t>
+            </a:r>
+          </a:p>
+          <a:p>
+            <a:pPr marL="285750" indent="-285750" rtl="0" fontAlgn="ctr">
+              <a:spcBef>
+                <a:spcPts val="0"/>
+              </a:spcBef>
+              <a:spcAft>
+                <a:spcPts val="0"/>
+              </a:spcAft>
+              <a:buFont typeface="Arial" panose="020B0604020202020204" pitchFamily="34" charset="0"/>
+              <a:buChar char="•"/>
+            </a:pPr>
+            <a:r>
+              <a:rPr lang="en-US" sz="1400" dirty="0">
+                <a:effectLst/>
+                <a:latin typeface="Century Gothic" panose="020B0502020202020204" pitchFamily="34" charset="0"/>
+              </a:rPr>
+              <a:t>Genre (M2M)</a:t>
+            </a:r>
+          </a:p>
+        </p:txBody>
+      </p:sp>
+      <p:sp>
+        <p:nvSpPr>
+          <p:cNvPr id="15" name="TextBox 14">
+            <a:extLst>
+              <a:ext uri="{FF2B5EF4-FFF2-40B4-BE49-F238E27FC236}">
+                <a16:creationId xmlns:a16="http://schemas.microsoft.com/office/drawing/2014/main" id="{FE2A754C-405F-64FB-0336-C9818AC1DF36}"/>
+              </a:ext>
+            </a:extLst>
+          </p:cNvPr>
+          <p:cNvSpPr txBox="1"/>
+          <p:nvPr/>
+        </p:nvSpPr>
+        <p:spPr>
+          <a:xfrm>
+            <a:off x="4663078" y="4318860"/>
+            <a:ext cx="1418006" cy="738664"/>
+          </a:xfrm>
+          <a:prstGeom prst="rect">
+            <a:avLst/>
+          </a:prstGeom>
+          <a:noFill/>
+          <a:ln>
+            <a:solidFill>
+              <a:schemeClr val="accent1">
+                <a:lumMod val="50000"/>
+              </a:schemeClr>
+            </a:solidFill>
+          </a:ln>
+        </p:spPr>
+        <p:txBody>
+          <a:bodyPr wrap="square">
+            <a:spAutoFit/>
+          </a:bodyPr>
+          <a:lstStyle/>
+          <a:p>
+            <a:pPr marL="0" marR="0">
+              <a:spcBef>
+                <a:spcPts val="0"/>
+              </a:spcBef>
+              <a:spcAft>
+                <a:spcPts val="0"/>
+              </a:spcAft>
+            </a:pPr>
+            <a:r>
+              <a:rPr lang="en-US" sz="1400" dirty="0">
+                <a:effectLst/>
+                <a:latin typeface="Century Gothic" panose="020B0502020202020204" pitchFamily="34" charset="0"/>
+              </a:rPr>
+              <a:t>Genre</a:t>
+            </a:r>
+          </a:p>
+          <a:p>
+            <a:pPr marL="285750" indent="-285750" rtl="0" fontAlgn="ctr">
+              <a:spcBef>
+                <a:spcPts val="0"/>
+              </a:spcBef>
+              <a:spcAft>
+                <a:spcPts val="0"/>
+              </a:spcAft>
+              <a:buFont typeface="Arial" panose="020B0604020202020204" pitchFamily="34" charset="0"/>
+              <a:buChar char="•"/>
+            </a:pPr>
+            <a:r>
+              <a:rPr lang="en-US" sz="1400" dirty="0">
+                <a:effectLst/>
+                <a:latin typeface="Century Gothic" panose="020B0502020202020204" pitchFamily="34" charset="0"/>
+              </a:rPr>
+              <a:t>Id(PK)</a:t>
+            </a:r>
+          </a:p>
+          <a:p>
+            <a:pPr marL="285750" indent="-285750" rtl="0" fontAlgn="ctr">
+              <a:spcBef>
+                <a:spcPts val="0"/>
+              </a:spcBef>
+              <a:spcAft>
+                <a:spcPts val="0"/>
+              </a:spcAft>
+              <a:buFont typeface="Arial" panose="020B0604020202020204" pitchFamily="34" charset="0"/>
+              <a:buChar char="•"/>
+            </a:pPr>
+            <a:r>
+              <a:rPr lang="en-US" sz="1400" dirty="0">
+                <a:effectLst/>
+                <a:latin typeface="Century Gothic" panose="020B0502020202020204" pitchFamily="34" charset="0"/>
+              </a:rPr>
+              <a:t>title</a:t>
+            </a:r>
+          </a:p>
+        </p:txBody>
+      </p:sp>
+      <p:sp>
+        <p:nvSpPr>
+          <p:cNvPr id="17" name="TextBox 16">
+            <a:extLst>
+              <a:ext uri="{FF2B5EF4-FFF2-40B4-BE49-F238E27FC236}">
+                <a16:creationId xmlns:a16="http://schemas.microsoft.com/office/drawing/2014/main" id="{132FEAA4-83A7-EC7C-9E0E-10C7F68D38CE}"/>
+              </a:ext>
+            </a:extLst>
+          </p:cNvPr>
+          <p:cNvSpPr txBox="1"/>
+          <p:nvPr/>
+        </p:nvSpPr>
+        <p:spPr>
+          <a:xfrm>
+            <a:off x="6912851" y="2079030"/>
+            <a:ext cx="5023335" cy="646331"/>
+          </a:xfrm>
+          <a:prstGeom prst="rect">
+            <a:avLst/>
+          </a:prstGeom>
+          <a:noFill/>
+          <a:ln>
+            <a:solidFill>
+              <a:schemeClr val="accent1">
+                <a:lumMod val="50000"/>
+              </a:schemeClr>
+            </a:solidFill>
+          </a:ln>
+        </p:spPr>
+        <p:txBody>
+          <a:bodyPr wrap="square">
+            <a:spAutoFit/>
+          </a:bodyPr>
+          <a:lstStyle/>
+          <a:p>
+            <a:pPr marL="0" marR="0">
+              <a:spcBef>
+                <a:spcPts val="0"/>
+              </a:spcBef>
+              <a:spcAft>
+                <a:spcPts val="0"/>
+              </a:spcAft>
+            </a:pPr>
+            <a:r>
+              <a:rPr lang="en-US" sz="1200" dirty="0">
+                <a:effectLst/>
+                <a:latin typeface="Century Gothic" panose="020B0502020202020204" pitchFamily="34" charset="0"/>
+              </a:rPr>
+              <a:t>Books that belong to Multiple Genre, One Genre can contain multiple Book</a:t>
+            </a:r>
+          </a:p>
+          <a:p>
+            <a:pPr marL="0" marR="0">
+              <a:spcBef>
+                <a:spcPts val="0"/>
+              </a:spcBef>
+              <a:spcAft>
+                <a:spcPts val="0"/>
+              </a:spcAft>
+            </a:pPr>
+            <a:r>
+              <a:rPr lang="en-US" sz="1200" b="1" dirty="0">
+                <a:effectLst/>
+                <a:latin typeface="Century Gothic" panose="020B0502020202020204" pitchFamily="34" charset="0"/>
+              </a:rPr>
+              <a:t>Many to Many Relationship</a:t>
+            </a:r>
+          </a:p>
+        </p:txBody>
+      </p:sp>
+      <p:sp>
+        <p:nvSpPr>
+          <p:cNvPr id="19" name="TextBox 18">
+            <a:extLst>
+              <a:ext uri="{FF2B5EF4-FFF2-40B4-BE49-F238E27FC236}">
+                <a16:creationId xmlns:a16="http://schemas.microsoft.com/office/drawing/2014/main" id="{0F7A6237-F46D-7BDB-FBD8-838FEB4A01A6}"/>
+              </a:ext>
+            </a:extLst>
+          </p:cNvPr>
+          <p:cNvSpPr txBox="1"/>
+          <p:nvPr/>
+        </p:nvSpPr>
+        <p:spPr>
+          <a:xfrm>
+            <a:off x="6912851" y="1501577"/>
+            <a:ext cx="3978441" cy="461665"/>
+          </a:xfrm>
+          <a:prstGeom prst="rect">
+            <a:avLst/>
+          </a:prstGeom>
+          <a:noFill/>
+          <a:ln>
+            <a:solidFill>
+              <a:schemeClr val="accent1">
+                <a:lumMod val="50000"/>
+              </a:schemeClr>
+            </a:solidFill>
+          </a:ln>
+        </p:spPr>
+        <p:txBody>
+          <a:bodyPr wrap="square">
+            <a:spAutoFit/>
+          </a:bodyPr>
+          <a:lstStyle/>
+          <a:p>
+            <a:pPr marL="0" marR="0">
+              <a:spcBef>
+                <a:spcPts val="0"/>
+              </a:spcBef>
+              <a:spcAft>
+                <a:spcPts val="0"/>
+              </a:spcAft>
+            </a:pPr>
+            <a:r>
+              <a:rPr lang="en-US" sz="1200" dirty="0">
+                <a:effectLst/>
+                <a:latin typeface="Century Gothic" panose="020B0502020202020204" pitchFamily="34" charset="0"/>
+              </a:rPr>
+              <a:t>Author that Wrote Multiple Books (FK)</a:t>
+            </a:r>
+          </a:p>
+          <a:p>
+            <a:pPr marL="0" marR="0">
+              <a:spcBef>
+                <a:spcPts val="0"/>
+              </a:spcBef>
+              <a:spcAft>
+                <a:spcPts val="0"/>
+              </a:spcAft>
+            </a:pPr>
+            <a:r>
+              <a:rPr lang="en-US" sz="1200" b="1" dirty="0">
+                <a:effectLst/>
+                <a:latin typeface="Century Gothic" panose="020B0502020202020204" pitchFamily="34" charset="0"/>
+              </a:rPr>
+              <a:t>One to Many Relationship</a:t>
+            </a:r>
+          </a:p>
+        </p:txBody>
+      </p:sp>
+      <p:sp>
+        <p:nvSpPr>
+          <p:cNvPr id="21" name="TextBox 20">
+            <a:extLst>
+              <a:ext uri="{FF2B5EF4-FFF2-40B4-BE49-F238E27FC236}">
+                <a16:creationId xmlns:a16="http://schemas.microsoft.com/office/drawing/2014/main" id="{740F33DB-7C88-8BFA-74A2-73618A708FF7}"/>
+              </a:ext>
+            </a:extLst>
+          </p:cNvPr>
+          <p:cNvSpPr txBox="1"/>
+          <p:nvPr/>
+        </p:nvSpPr>
+        <p:spPr>
+          <a:xfrm>
+            <a:off x="6912851" y="924124"/>
+            <a:ext cx="2774566" cy="461665"/>
+          </a:xfrm>
+          <a:prstGeom prst="rect">
+            <a:avLst/>
+          </a:prstGeom>
+          <a:noFill/>
+          <a:ln>
+            <a:solidFill>
+              <a:schemeClr val="accent1">
+                <a:lumMod val="50000"/>
+              </a:schemeClr>
+            </a:solidFill>
+          </a:ln>
+        </p:spPr>
+        <p:txBody>
+          <a:bodyPr wrap="square">
+            <a:spAutoFit/>
+          </a:bodyPr>
+          <a:lstStyle/>
+          <a:p>
+            <a:r>
+              <a:rPr lang="en-US" sz="1200" dirty="0">
+                <a:latin typeface="Century Gothic" panose="020B0502020202020204" pitchFamily="34" charset="0"/>
+              </a:rPr>
+              <a:t>One User to User Profile</a:t>
+            </a:r>
+          </a:p>
+          <a:p>
+            <a:r>
+              <a:rPr lang="en-US" sz="1200" b="1" dirty="0">
+                <a:latin typeface="Century Gothic" panose="020B0502020202020204" pitchFamily="34" charset="0"/>
+              </a:rPr>
+              <a:t>One to One Relationship</a:t>
+            </a:r>
+          </a:p>
+        </p:txBody>
+      </p:sp>
+      <p:sp>
+        <p:nvSpPr>
+          <p:cNvPr id="35" name="TextBox 34">
+            <a:extLst>
+              <a:ext uri="{FF2B5EF4-FFF2-40B4-BE49-F238E27FC236}">
+                <a16:creationId xmlns:a16="http://schemas.microsoft.com/office/drawing/2014/main" id="{E5C33A5A-CAE6-15C9-5A92-001418AC4B05}"/>
+              </a:ext>
+            </a:extLst>
+          </p:cNvPr>
+          <p:cNvSpPr txBox="1"/>
+          <p:nvPr/>
+        </p:nvSpPr>
+        <p:spPr>
+          <a:xfrm>
+            <a:off x="3622563" y="0"/>
+            <a:ext cx="4946875" cy="369332"/>
+          </a:xfrm>
+          <a:prstGeom prst="rect">
+            <a:avLst/>
+          </a:prstGeom>
+          <a:noFill/>
+        </p:spPr>
+        <p:txBody>
+          <a:bodyPr wrap="square" rtlCol="0">
+            <a:spAutoFit/>
+          </a:bodyPr>
+          <a:lstStyle/>
+          <a:p>
+            <a:pPr algn="ctr"/>
+            <a:r>
+              <a:rPr lang="en-US" b="1" dirty="0">
+                <a:latin typeface="Century Gothic" panose="020B0502020202020204" pitchFamily="34" charset="0"/>
+              </a:rPr>
+              <a:t>LIBRARY MANAGEMENT SYSTEM DESIGN</a:t>
+            </a:r>
+          </a:p>
+        </p:txBody>
+      </p:sp>
+      <p:sp>
+        <p:nvSpPr>
+          <p:cNvPr id="32" name="TextBox 31">
+            <a:extLst>
+              <a:ext uri="{FF2B5EF4-FFF2-40B4-BE49-F238E27FC236}">
+                <a16:creationId xmlns:a16="http://schemas.microsoft.com/office/drawing/2014/main" id="{7BFEB2E7-1845-4DAC-D704-AC641C5E4850}"/>
+              </a:ext>
+            </a:extLst>
+          </p:cNvPr>
+          <p:cNvSpPr txBox="1"/>
+          <p:nvPr/>
+        </p:nvSpPr>
+        <p:spPr>
+          <a:xfrm>
+            <a:off x="368491" y="3887973"/>
+            <a:ext cx="1796716" cy="1600438"/>
+          </a:xfrm>
+          <a:prstGeom prst="rect">
+            <a:avLst/>
+          </a:prstGeom>
+          <a:noFill/>
+          <a:ln>
+            <a:solidFill>
+              <a:schemeClr val="accent1">
+                <a:lumMod val="50000"/>
+              </a:schemeClr>
+            </a:solidFill>
+          </a:ln>
+        </p:spPr>
+        <p:txBody>
+          <a:bodyPr wrap="square">
+            <a:spAutoFit/>
+          </a:bodyPr>
+          <a:lstStyle/>
+          <a:p>
+            <a:pPr marL="0" marR="0">
+              <a:spcBef>
+                <a:spcPts val="0"/>
+              </a:spcBef>
+              <a:spcAft>
+                <a:spcPts val="0"/>
+              </a:spcAft>
+            </a:pPr>
+            <a:r>
+              <a:rPr lang="en-US" sz="1400" dirty="0">
+                <a:effectLst/>
+                <a:latin typeface="Century Gothic" panose="020B0502020202020204" pitchFamily="34" charset="0"/>
+              </a:rPr>
+              <a:t>Books</a:t>
+            </a:r>
+          </a:p>
+          <a:p>
+            <a:pPr marL="285750" indent="-285750" rtl="0" fontAlgn="ctr">
+              <a:spcBef>
+                <a:spcPts val="0"/>
+              </a:spcBef>
+              <a:spcAft>
+                <a:spcPts val="0"/>
+              </a:spcAft>
+              <a:buFont typeface="Arial" panose="020B0604020202020204" pitchFamily="34" charset="0"/>
+              <a:buChar char="•"/>
+            </a:pPr>
+            <a:r>
+              <a:rPr lang="en-US" sz="1400" dirty="0">
+                <a:effectLst/>
+                <a:latin typeface="Century Gothic" panose="020B0502020202020204" pitchFamily="34" charset="0"/>
+              </a:rPr>
+              <a:t>id</a:t>
+            </a:r>
+          </a:p>
+          <a:p>
+            <a:pPr marL="285750" indent="-285750" rtl="0" fontAlgn="ctr">
+              <a:spcBef>
+                <a:spcPts val="0"/>
+              </a:spcBef>
+              <a:spcAft>
+                <a:spcPts val="0"/>
+              </a:spcAft>
+              <a:buFont typeface="Arial" panose="020B0604020202020204" pitchFamily="34" charset="0"/>
+              <a:buChar char="•"/>
+            </a:pPr>
+            <a:r>
+              <a:rPr lang="en-US" sz="1400" dirty="0">
+                <a:effectLst/>
+                <a:latin typeface="Century Gothic" panose="020B0502020202020204" pitchFamily="34" charset="0"/>
+              </a:rPr>
+              <a:t>Title</a:t>
+            </a:r>
+          </a:p>
+          <a:p>
+            <a:pPr marL="285750" indent="-285750" rtl="0" fontAlgn="ctr">
+              <a:spcBef>
+                <a:spcPts val="0"/>
+              </a:spcBef>
+              <a:spcAft>
+                <a:spcPts val="0"/>
+              </a:spcAft>
+              <a:buFont typeface="Arial" panose="020B0604020202020204" pitchFamily="34" charset="0"/>
+              <a:buChar char="•"/>
+            </a:pPr>
+            <a:r>
+              <a:rPr lang="en-US" sz="1400" dirty="0">
+                <a:effectLst/>
+                <a:latin typeface="Century Gothic" panose="020B0502020202020204" pitchFamily="34" charset="0"/>
+              </a:rPr>
+              <a:t>Isbn</a:t>
+            </a:r>
+            <a:endParaRPr lang="en-US" sz="1400" dirty="0">
+              <a:latin typeface="Century Gothic" panose="020B0502020202020204" pitchFamily="34" charset="0"/>
+            </a:endParaRPr>
+          </a:p>
+          <a:p>
+            <a:pPr marL="285750" indent="-285750" rtl="0" fontAlgn="ctr">
+              <a:spcBef>
+                <a:spcPts val="0"/>
+              </a:spcBef>
+              <a:spcAft>
+                <a:spcPts val="0"/>
+              </a:spcAft>
+              <a:buFont typeface="Arial" panose="020B0604020202020204" pitchFamily="34" charset="0"/>
+              <a:buChar char="•"/>
+            </a:pPr>
+            <a:r>
+              <a:rPr lang="en-US" sz="1400" dirty="0">
+                <a:effectLst/>
+                <a:latin typeface="Century Gothic" panose="020B0502020202020204" pitchFamily="34" charset="0"/>
+              </a:rPr>
+              <a:t>Author (FK)</a:t>
+            </a:r>
+          </a:p>
+          <a:p>
+            <a:pPr marL="285750" indent="-285750" rtl="0" fontAlgn="ctr">
+              <a:spcBef>
+                <a:spcPts val="0"/>
+              </a:spcBef>
+              <a:spcAft>
+                <a:spcPts val="0"/>
+              </a:spcAft>
+              <a:buFont typeface="Arial" panose="020B0604020202020204" pitchFamily="34" charset="0"/>
+              <a:buChar char="•"/>
+            </a:pPr>
+            <a:r>
+              <a:rPr lang="en-US" sz="1400" dirty="0">
+                <a:effectLst/>
+                <a:latin typeface="Century Gothic" panose="020B0502020202020204" pitchFamily="34" charset="0"/>
+              </a:rPr>
+              <a:t>Published date</a:t>
+            </a:r>
+          </a:p>
+          <a:p>
+            <a:pPr marL="285750" indent="-285750" rtl="0" fontAlgn="ctr">
+              <a:spcBef>
+                <a:spcPts val="0"/>
+              </a:spcBef>
+              <a:spcAft>
+                <a:spcPts val="0"/>
+              </a:spcAft>
+              <a:buFont typeface="Arial" panose="020B0604020202020204" pitchFamily="34" charset="0"/>
+              <a:buChar char="•"/>
+            </a:pPr>
+            <a:r>
+              <a:rPr lang="en-US" sz="1400" dirty="0">
+                <a:effectLst/>
+                <a:latin typeface="Century Gothic" panose="020B0502020202020204" pitchFamily="34" charset="0"/>
+              </a:rPr>
+              <a:t>Genre (M2M)</a:t>
+            </a:r>
+          </a:p>
+        </p:txBody>
+      </p:sp>
+      <p:cxnSp>
+        <p:nvCxnSpPr>
+          <p:cNvPr id="36" name="Straight Arrow Connector 35">
+            <a:extLst>
+              <a:ext uri="{FF2B5EF4-FFF2-40B4-BE49-F238E27FC236}">
+                <a16:creationId xmlns:a16="http://schemas.microsoft.com/office/drawing/2014/main" id="{34D4A19C-AC9A-352D-3CA7-2B1919F7AE4F}"/>
+              </a:ext>
+            </a:extLst>
+          </p:cNvPr>
+          <p:cNvCxnSpPr>
+            <a:cxnSpLocks/>
+          </p:cNvCxnSpPr>
+          <p:nvPr/>
+        </p:nvCxnSpPr>
+        <p:spPr>
+          <a:xfrm>
+            <a:off x="2165207" y="4412146"/>
+            <a:ext cx="2497871" cy="0"/>
+          </a:xfrm>
+          <a:prstGeom prst="straightConnector1">
+            <a:avLst/>
+          </a:prstGeom>
+          <a:ln w="38100">
+            <a:tailEnd type="triangle"/>
+          </a:ln>
+        </p:spPr>
+        <p:style>
+          <a:lnRef idx="2">
+            <a:schemeClr val="dk1"/>
+          </a:lnRef>
+          <a:fillRef idx="0">
+            <a:schemeClr val="dk1"/>
+          </a:fillRef>
+          <a:effectRef idx="1">
+            <a:schemeClr val="dk1"/>
+          </a:effectRef>
+          <a:fontRef idx="minor">
+            <a:schemeClr val="tx1"/>
+          </a:fontRef>
+        </p:style>
+      </p:cxnSp>
+      <p:cxnSp>
+        <p:nvCxnSpPr>
+          <p:cNvPr id="38" name="Straight Arrow Connector 37">
+            <a:extLst>
+              <a:ext uri="{FF2B5EF4-FFF2-40B4-BE49-F238E27FC236}">
+                <a16:creationId xmlns:a16="http://schemas.microsoft.com/office/drawing/2014/main" id="{60CE4240-D8EF-CE03-A1FB-5F50B99F8A12}"/>
+              </a:ext>
+            </a:extLst>
+          </p:cNvPr>
+          <p:cNvCxnSpPr>
+            <a:cxnSpLocks/>
+          </p:cNvCxnSpPr>
+          <p:nvPr/>
+        </p:nvCxnSpPr>
+        <p:spPr>
+          <a:xfrm flipH="1">
+            <a:off x="2165207" y="4903848"/>
+            <a:ext cx="2497871" cy="0"/>
+          </a:xfrm>
+          <a:prstGeom prst="straightConnector1">
+            <a:avLst/>
+          </a:prstGeom>
+          <a:ln w="38100">
+            <a:tailEnd type="triangle"/>
+          </a:ln>
+        </p:spPr>
+        <p:style>
+          <a:lnRef idx="2">
+            <a:schemeClr val="dk1"/>
+          </a:lnRef>
+          <a:fillRef idx="0">
+            <a:schemeClr val="dk1"/>
+          </a:fillRef>
+          <a:effectRef idx="1">
+            <a:schemeClr val="dk1"/>
+          </a:effectRef>
+          <a:fontRef idx="minor">
+            <a:schemeClr val="tx1"/>
+          </a:fontRef>
+        </p:style>
+      </p:cxnSp>
+      <p:cxnSp>
+        <p:nvCxnSpPr>
+          <p:cNvPr id="39" name="Straight Arrow Connector 38">
+            <a:extLst>
+              <a:ext uri="{FF2B5EF4-FFF2-40B4-BE49-F238E27FC236}">
+                <a16:creationId xmlns:a16="http://schemas.microsoft.com/office/drawing/2014/main" id="{9DDB240C-6844-702F-59FA-468EBB6F5D87}"/>
+              </a:ext>
+            </a:extLst>
+          </p:cNvPr>
+          <p:cNvCxnSpPr>
+            <a:cxnSpLocks/>
+          </p:cNvCxnSpPr>
+          <p:nvPr/>
+        </p:nvCxnSpPr>
+        <p:spPr>
+          <a:xfrm>
+            <a:off x="2087566" y="1867353"/>
+            <a:ext cx="2497871" cy="0"/>
+          </a:xfrm>
+          <a:prstGeom prst="straightConnector1">
+            <a:avLst/>
+          </a:prstGeom>
+          <a:ln w="38100">
+            <a:tailEnd type="triangle"/>
+          </a:ln>
+        </p:spPr>
+        <p:style>
+          <a:lnRef idx="2">
+            <a:schemeClr val="dk1"/>
+          </a:lnRef>
+          <a:fillRef idx="0">
+            <a:schemeClr val="dk1"/>
+          </a:fillRef>
+          <a:effectRef idx="1">
+            <a:schemeClr val="dk1"/>
+          </a:effectRef>
+          <a:fontRef idx="minor">
+            <a:schemeClr val="tx1"/>
+          </a:fontRef>
+        </p:style>
+      </p:cxnSp>
+      <p:cxnSp>
+        <p:nvCxnSpPr>
+          <p:cNvPr id="40" name="Straight Arrow Connector 39">
+            <a:extLst>
+              <a:ext uri="{FF2B5EF4-FFF2-40B4-BE49-F238E27FC236}">
+                <a16:creationId xmlns:a16="http://schemas.microsoft.com/office/drawing/2014/main" id="{8E28A31D-4F27-429C-BDD0-4C4764D70065}"/>
+              </a:ext>
+            </a:extLst>
+          </p:cNvPr>
+          <p:cNvCxnSpPr>
+            <a:cxnSpLocks/>
+          </p:cNvCxnSpPr>
+          <p:nvPr/>
+        </p:nvCxnSpPr>
+        <p:spPr>
+          <a:xfrm flipH="1">
+            <a:off x="2087566" y="2359055"/>
+            <a:ext cx="2497871" cy="0"/>
+          </a:xfrm>
+          <a:prstGeom prst="straightConnector1">
+            <a:avLst/>
+          </a:prstGeom>
+          <a:ln w="38100">
+            <a:tailEnd type="triangle"/>
+          </a:ln>
+        </p:spPr>
+        <p:style>
+          <a:lnRef idx="2">
+            <a:schemeClr val="dk1"/>
+          </a:lnRef>
+          <a:fillRef idx="0">
+            <a:schemeClr val="dk1"/>
+          </a:fillRef>
+          <a:effectRef idx="1">
+            <a:schemeClr val="dk1"/>
+          </a:effectRef>
+          <a:fontRef idx="minor">
+            <a:schemeClr val="tx1"/>
+          </a:fontRef>
+        </p:style>
+      </p:cxnSp>
+      <p:sp>
+        <p:nvSpPr>
+          <p:cNvPr id="41" name="TextBox 40">
+            <a:extLst>
+              <a:ext uri="{FF2B5EF4-FFF2-40B4-BE49-F238E27FC236}">
+                <a16:creationId xmlns:a16="http://schemas.microsoft.com/office/drawing/2014/main" id="{EC60263B-5B7E-98C5-59CF-EEE78AA0D4F5}"/>
+              </a:ext>
+            </a:extLst>
+          </p:cNvPr>
+          <p:cNvSpPr txBox="1"/>
+          <p:nvPr/>
+        </p:nvSpPr>
+        <p:spPr>
+          <a:xfrm>
+            <a:off x="2238771" y="1528693"/>
+            <a:ext cx="2161885" cy="276999"/>
+          </a:xfrm>
+          <a:prstGeom prst="rect">
+            <a:avLst/>
+          </a:prstGeom>
+          <a:noFill/>
+        </p:spPr>
+        <p:txBody>
+          <a:bodyPr wrap="square" rtlCol="0">
+            <a:spAutoFit/>
+          </a:bodyPr>
+          <a:lstStyle/>
+          <a:p>
+            <a:r>
+              <a:rPr lang="en-US" sz="1200" dirty="0">
+                <a:latin typeface="Century Gothic" panose="020B0502020202020204" pitchFamily="34" charset="0"/>
+              </a:rPr>
+              <a:t>(FK)Forward Relationship</a:t>
+            </a:r>
+          </a:p>
+        </p:txBody>
+      </p:sp>
+      <p:sp>
+        <p:nvSpPr>
+          <p:cNvPr id="42" name="TextBox 41">
+            <a:extLst>
+              <a:ext uri="{FF2B5EF4-FFF2-40B4-BE49-F238E27FC236}">
+                <a16:creationId xmlns:a16="http://schemas.microsoft.com/office/drawing/2014/main" id="{2068D3A4-F665-FA39-C415-5C5653F76C22}"/>
+              </a:ext>
+            </a:extLst>
+          </p:cNvPr>
+          <p:cNvSpPr txBox="1"/>
+          <p:nvPr/>
+        </p:nvSpPr>
+        <p:spPr>
+          <a:xfrm>
+            <a:off x="2415567" y="2409549"/>
+            <a:ext cx="1968007" cy="276999"/>
+          </a:xfrm>
+          <a:prstGeom prst="rect">
+            <a:avLst/>
+          </a:prstGeom>
+          <a:noFill/>
+        </p:spPr>
+        <p:txBody>
+          <a:bodyPr wrap="square" rtlCol="0">
+            <a:spAutoFit/>
+          </a:bodyPr>
+          <a:lstStyle/>
+          <a:p>
+            <a:r>
+              <a:rPr lang="en-US" sz="1200" dirty="0">
+                <a:latin typeface="Century Gothic" panose="020B0502020202020204" pitchFamily="34" charset="0"/>
+              </a:rPr>
+              <a:t>(FK)Reverse Relationship</a:t>
+            </a:r>
+          </a:p>
+        </p:txBody>
+      </p:sp>
+      <p:sp>
+        <p:nvSpPr>
+          <p:cNvPr id="43" name="TextBox 42">
+            <a:extLst>
+              <a:ext uri="{FF2B5EF4-FFF2-40B4-BE49-F238E27FC236}">
+                <a16:creationId xmlns:a16="http://schemas.microsoft.com/office/drawing/2014/main" id="{44231032-1729-9476-B596-242232381A83}"/>
+              </a:ext>
+            </a:extLst>
+          </p:cNvPr>
+          <p:cNvSpPr txBox="1"/>
+          <p:nvPr/>
+        </p:nvSpPr>
+        <p:spPr>
+          <a:xfrm>
+            <a:off x="2238772" y="4027796"/>
+            <a:ext cx="2424306" cy="276999"/>
+          </a:xfrm>
+          <a:prstGeom prst="rect">
+            <a:avLst/>
+          </a:prstGeom>
+          <a:noFill/>
+        </p:spPr>
+        <p:txBody>
+          <a:bodyPr wrap="square" rtlCol="0">
+            <a:spAutoFit/>
+          </a:bodyPr>
+          <a:lstStyle/>
+          <a:p>
+            <a:r>
+              <a:rPr lang="en-US" sz="1200" dirty="0">
+                <a:latin typeface="Century Gothic" panose="020B0502020202020204" pitchFamily="34" charset="0"/>
+              </a:rPr>
+              <a:t>(M2M) Forward Relationship</a:t>
+            </a:r>
+          </a:p>
+        </p:txBody>
+      </p:sp>
+      <p:sp>
+        <p:nvSpPr>
+          <p:cNvPr id="44" name="TextBox 43">
+            <a:extLst>
+              <a:ext uri="{FF2B5EF4-FFF2-40B4-BE49-F238E27FC236}">
+                <a16:creationId xmlns:a16="http://schemas.microsoft.com/office/drawing/2014/main" id="{1A85251C-E359-4BDE-83CA-D35114761D30}"/>
+              </a:ext>
+            </a:extLst>
+          </p:cNvPr>
+          <p:cNvSpPr txBox="1"/>
+          <p:nvPr/>
+        </p:nvSpPr>
+        <p:spPr>
+          <a:xfrm>
+            <a:off x="3167744" y="4955639"/>
+            <a:ext cx="695648" cy="276999"/>
+          </a:xfrm>
+          <a:prstGeom prst="rect">
+            <a:avLst/>
+          </a:prstGeom>
+          <a:noFill/>
+        </p:spPr>
+        <p:txBody>
+          <a:bodyPr wrap="square" rtlCol="0">
+            <a:spAutoFit/>
+          </a:bodyPr>
+          <a:lstStyle/>
+          <a:p>
+            <a:r>
+              <a:rPr lang="en-US" sz="1200" dirty="0">
+                <a:latin typeface="Century Gothic" panose="020B0502020202020204" pitchFamily="34" charset="0"/>
+              </a:rPr>
+              <a:t>(M2M)</a:t>
+            </a:r>
+          </a:p>
+        </p:txBody>
+      </p:sp>
+      <p:sp>
+        <p:nvSpPr>
+          <p:cNvPr id="45" name="TextBox 44">
+            <a:extLst>
+              <a:ext uri="{FF2B5EF4-FFF2-40B4-BE49-F238E27FC236}">
+                <a16:creationId xmlns:a16="http://schemas.microsoft.com/office/drawing/2014/main" id="{EDDE9E01-BAC1-3E45-C026-E52F3A3B2D43}"/>
+              </a:ext>
+            </a:extLst>
+          </p:cNvPr>
+          <p:cNvSpPr txBox="1"/>
+          <p:nvPr/>
+        </p:nvSpPr>
+        <p:spPr>
+          <a:xfrm>
+            <a:off x="2415567" y="1154956"/>
+            <a:ext cx="1808293" cy="369332"/>
+          </a:xfrm>
+          <a:prstGeom prst="rect">
+            <a:avLst/>
+          </a:prstGeom>
+          <a:noFill/>
+        </p:spPr>
+        <p:txBody>
+          <a:bodyPr wrap="square" rtlCol="0">
+            <a:spAutoFit/>
+          </a:bodyPr>
+          <a:lstStyle/>
+          <a:p>
+            <a:r>
+              <a:rPr lang="en-US" dirty="0"/>
+              <a:t>Select_related</a:t>
+            </a:r>
+          </a:p>
+        </p:txBody>
+      </p:sp>
+      <p:sp>
+        <p:nvSpPr>
+          <p:cNvPr id="46" name="TextBox 45">
+            <a:extLst>
+              <a:ext uri="{FF2B5EF4-FFF2-40B4-BE49-F238E27FC236}">
+                <a16:creationId xmlns:a16="http://schemas.microsoft.com/office/drawing/2014/main" id="{88A1BABF-E088-2AD4-752C-F48C0855DB76}"/>
+              </a:ext>
+            </a:extLst>
+          </p:cNvPr>
+          <p:cNvSpPr txBox="1"/>
+          <p:nvPr/>
+        </p:nvSpPr>
+        <p:spPr>
+          <a:xfrm>
+            <a:off x="2466921" y="2639428"/>
+            <a:ext cx="1968007" cy="369332"/>
+          </a:xfrm>
+          <a:prstGeom prst="rect">
+            <a:avLst/>
+          </a:prstGeom>
+          <a:noFill/>
+        </p:spPr>
+        <p:txBody>
+          <a:bodyPr wrap="square" rtlCol="0">
+            <a:spAutoFit/>
+          </a:bodyPr>
+          <a:lstStyle/>
+          <a:p>
+            <a:r>
+              <a:rPr lang="en-US" dirty="0"/>
+              <a:t>Prefetch_related</a:t>
+            </a:r>
+          </a:p>
+        </p:txBody>
+      </p:sp>
+      <p:sp>
+        <p:nvSpPr>
+          <p:cNvPr id="47" name="TextBox 46">
+            <a:extLst>
+              <a:ext uri="{FF2B5EF4-FFF2-40B4-BE49-F238E27FC236}">
+                <a16:creationId xmlns:a16="http://schemas.microsoft.com/office/drawing/2014/main" id="{B5153CF1-4FA2-DEE2-1107-9506626C2A7D}"/>
+              </a:ext>
+            </a:extLst>
+          </p:cNvPr>
+          <p:cNvSpPr txBox="1"/>
+          <p:nvPr/>
+        </p:nvSpPr>
+        <p:spPr>
+          <a:xfrm>
+            <a:off x="2933333" y="4503526"/>
+            <a:ext cx="1146961" cy="369332"/>
+          </a:xfrm>
+          <a:prstGeom prst="rect">
+            <a:avLst/>
+          </a:prstGeom>
+          <a:noFill/>
+        </p:spPr>
+        <p:txBody>
+          <a:bodyPr wrap="square" rtlCol="0">
+            <a:spAutoFit/>
+          </a:bodyPr>
+          <a:lstStyle/>
+          <a:p>
+            <a:r>
+              <a:rPr lang="en-US" dirty="0"/>
+              <a:t>prefetch</a:t>
+            </a:r>
+          </a:p>
+        </p:txBody>
+      </p:sp>
+      <p:sp>
+        <p:nvSpPr>
+          <p:cNvPr id="48" name="TextBox 47">
+            <a:extLst>
+              <a:ext uri="{FF2B5EF4-FFF2-40B4-BE49-F238E27FC236}">
+                <a16:creationId xmlns:a16="http://schemas.microsoft.com/office/drawing/2014/main" id="{F66943FF-D950-795F-E03F-DDEA16259C7B}"/>
+              </a:ext>
+            </a:extLst>
+          </p:cNvPr>
+          <p:cNvSpPr txBox="1"/>
+          <p:nvPr/>
+        </p:nvSpPr>
+        <p:spPr>
+          <a:xfrm>
+            <a:off x="9998318" y="3990708"/>
+            <a:ext cx="1825191" cy="1384995"/>
+          </a:xfrm>
+          <a:prstGeom prst="rect">
+            <a:avLst/>
+          </a:prstGeom>
+          <a:noFill/>
+          <a:ln>
+            <a:solidFill>
+              <a:schemeClr val="accent1">
+                <a:lumMod val="50000"/>
+              </a:schemeClr>
+            </a:solidFill>
+          </a:ln>
+        </p:spPr>
+        <p:txBody>
+          <a:bodyPr wrap="square">
+            <a:spAutoFit/>
+          </a:bodyPr>
+          <a:lstStyle/>
+          <a:p>
+            <a:pPr marL="0" marR="0">
+              <a:spcBef>
+                <a:spcPts val="0"/>
+              </a:spcBef>
+              <a:spcAft>
+                <a:spcPts val="0"/>
+              </a:spcAft>
+            </a:pPr>
+            <a:r>
+              <a:rPr lang="en-US" sz="1400" dirty="0">
+                <a:effectLst/>
+                <a:latin typeface="Century Gothic" panose="020B0502020202020204" pitchFamily="34" charset="0"/>
+              </a:rPr>
+              <a:t>User Profile</a:t>
+            </a:r>
+          </a:p>
+          <a:p>
+            <a:pPr marL="285750" indent="-285750" rtl="0" fontAlgn="ctr">
+              <a:spcBef>
+                <a:spcPts val="0"/>
+              </a:spcBef>
+              <a:spcAft>
+                <a:spcPts val="0"/>
+              </a:spcAft>
+              <a:buFont typeface="Arial" panose="020B0604020202020204" pitchFamily="34" charset="0"/>
+              <a:buChar char="•"/>
+            </a:pPr>
+            <a:r>
+              <a:rPr lang="en-US" sz="1400" dirty="0" err="1">
+                <a:effectLst/>
+                <a:latin typeface="Century Gothic" panose="020B0502020202020204" pitchFamily="34" charset="0"/>
+              </a:rPr>
+              <a:t>user</a:t>
+            </a:r>
+            <a:r>
+              <a:rPr lang="en-US" sz="1400" dirty="0" err="1">
+                <a:latin typeface="Century Gothic" panose="020B0502020202020204" pitchFamily="34" charset="0"/>
+              </a:rPr>
+              <a:t>_</a:t>
+            </a:r>
+            <a:r>
+              <a:rPr lang="en-US" sz="1400" dirty="0" err="1">
+                <a:effectLst/>
+                <a:latin typeface="Century Gothic" panose="020B0502020202020204" pitchFamily="34" charset="0"/>
+              </a:rPr>
+              <a:t>id</a:t>
+            </a:r>
+            <a:r>
+              <a:rPr lang="en-US" sz="1400" dirty="0">
+                <a:effectLst/>
+                <a:latin typeface="Century Gothic" panose="020B0502020202020204" pitchFamily="34" charset="0"/>
+              </a:rPr>
+              <a:t>(1to1)</a:t>
+            </a:r>
+            <a:endParaRPr lang="en-US" sz="1400" dirty="0">
+              <a:latin typeface="Century Gothic" panose="020B0502020202020204" pitchFamily="34" charset="0"/>
+            </a:endParaRPr>
+          </a:p>
+          <a:p>
+            <a:pPr marL="285750" indent="-285750" rtl="0" fontAlgn="ctr">
+              <a:spcBef>
+                <a:spcPts val="0"/>
+              </a:spcBef>
+              <a:spcAft>
+                <a:spcPts val="0"/>
+              </a:spcAft>
+              <a:buFont typeface="Arial" panose="020B0604020202020204" pitchFamily="34" charset="0"/>
+              <a:buChar char="•"/>
+            </a:pPr>
+            <a:r>
+              <a:rPr lang="en-US" sz="1400" dirty="0">
+                <a:effectLst/>
+                <a:latin typeface="Century Gothic" panose="020B0502020202020204" pitchFamily="34" charset="0"/>
+              </a:rPr>
+              <a:t>Address</a:t>
+            </a:r>
+            <a:endParaRPr lang="en-US" sz="1400" dirty="0">
+              <a:latin typeface="Century Gothic" panose="020B0502020202020204" pitchFamily="34" charset="0"/>
+            </a:endParaRPr>
+          </a:p>
+          <a:p>
+            <a:pPr marL="285750" indent="-285750" rtl="0" fontAlgn="ctr">
+              <a:spcBef>
+                <a:spcPts val="0"/>
+              </a:spcBef>
+              <a:spcAft>
+                <a:spcPts val="0"/>
+              </a:spcAft>
+              <a:buFont typeface="Arial" panose="020B0604020202020204" pitchFamily="34" charset="0"/>
+              <a:buChar char="•"/>
+            </a:pPr>
+            <a:r>
+              <a:rPr lang="en-US" sz="1400" dirty="0">
+                <a:effectLst/>
+                <a:latin typeface="Century Gothic" panose="020B0502020202020204" pitchFamily="34" charset="0"/>
+              </a:rPr>
+              <a:t>City</a:t>
+            </a:r>
+            <a:endParaRPr lang="en-US" sz="1400" dirty="0">
+              <a:latin typeface="Century Gothic" panose="020B0502020202020204" pitchFamily="34" charset="0"/>
+            </a:endParaRPr>
+          </a:p>
+          <a:p>
+            <a:pPr marL="285750" indent="-285750" rtl="0" fontAlgn="ctr">
+              <a:spcBef>
+                <a:spcPts val="0"/>
+              </a:spcBef>
+              <a:spcAft>
+                <a:spcPts val="0"/>
+              </a:spcAft>
+              <a:buFont typeface="Arial" panose="020B0604020202020204" pitchFamily="34" charset="0"/>
+              <a:buChar char="•"/>
+            </a:pPr>
+            <a:r>
+              <a:rPr lang="en-US" sz="1400" dirty="0">
+                <a:effectLst/>
+                <a:latin typeface="Century Gothic" panose="020B0502020202020204" pitchFamily="34" charset="0"/>
+              </a:rPr>
+              <a:t>Country</a:t>
+            </a:r>
+            <a:endParaRPr lang="en-US" sz="1400" dirty="0">
+              <a:latin typeface="Century Gothic" panose="020B0502020202020204" pitchFamily="34" charset="0"/>
+            </a:endParaRPr>
+          </a:p>
+          <a:p>
+            <a:pPr marL="285750" indent="-285750" rtl="0" fontAlgn="ctr">
+              <a:spcBef>
+                <a:spcPts val="0"/>
+              </a:spcBef>
+              <a:spcAft>
+                <a:spcPts val="0"/>
+              </a:spcAft>
+              <a:buFont typeface="Arial" panose="020B0604020202020204" pitchFamily="34" charset="0"/>
+              <a:buChar char="•"/>
+            </a:pPr>
+            <a:r>
+              <a:rPr lang="en-US" sz="1400" dirty="0">
+                <a:effectLst/>
+                <a:latin typeface="Century Gothic" panose="020B0502020202020204" pitchFamily="34" charset="0"/>
+              </a:rPr>
+              <a:t>Phone number</a:t>
+            </a:r>
+          </a:p>
+        </p:txBody>
+      </p:sp>
+      <p:sp>
+        <p:nvSpPr>
+          <p:cNvPr id="49" name="TextBox 48">
+            <a:extLst>
+              <a:ext uri="{FF2B5EF4-FFF2-40B4-BE49-F238E27FC236}">
+                <a16:creationId xmlns:a16="http://schemas.microsoft.com/office/drawing/2014/main" id="{AA36F26F-BDB6-410A-52F4-0A8003AF476C}"/>
+              </a:ext>
+            </a:extLst>
+          </p:cNvPr>
+          <p:cNvSpPr txBox="1"/>
+          <p:nvPr/>
+        </p:nvSpPr>
+        <p:spPr>
+          <a:xfrm>
+            <a:off x="6240577" y="3882986"/>
+            <a:ext cx="2059557" cy="1600438"/>
+          </a:xfrm>
+          <a:prstGeom prst="rect">
+            <a:avLst/>
+          </a:prstGeom>
+          <a:noFill/>
+          <a:ln>
+            <a:solidFill>
+              <a:schemeClr val="accent1">
+                <a:lumMod val="50000"/>
+              </a:schemeClr>
+            </a:solidFill>
+          </a:ln>
+        </p:spPr>
+        <p:txBody>
+          <a:bodyPr wrap="square">
+            <a:spAutoFit/>
+          </a:bodyPr>
+          <a:lstStyle/>
+          <a:p>
+            <a:pPr marL="0" marR="0">
+              <a:spcBef>
+                <a:spcPts val="0"/>
+              </a:spcBef>
+              <a:spcAft>
+                <a:spcPts val="0"/>
+              </a:spcAft>
+            </a:pPr>
+            <a:r>
+              <a:rPr lang="en-US" sz="1400" dirty="0">
+                <a:effectLst/>
+                <a:latin typeface="Century Gothic" panose="020B0502020202020204" pitchFamily="34" charset="0"/>
+              </a:rPr>
+              <a:t>Users records</a:t>
+            </a:r>
+          </a:p>
+          <a:p>
+            <a:pPr marL="285750" marR="0" indent="-285750">
+              <a:spcBef>
+                <a:spcPts val="0"/>
+              </a:spcBef>
+              <a:spcAft>
+                <a:spcPts val="0"/>
+              </a:spcAft>
+              <a:buFont typeface="Arial" panose="020B0604020202020204" pitchFamily="34" charset="0"/>
+              <a:buChar char="•"/>
+            </a:pPr>
+            <a:r>
+              <a:rPr lang="en-US" sz="1400" dirty="0">
+                <a:effectLst/>
+                <a:latin typeface="Century Gothic" panose="020B0502020202020204" pitchFamily="34" charset="0"/>
+              </a:rPr>
+              <a:t>Id(pk)</a:t>
+            </a:r>
+          </a:p>
+          <a:p>
+            <a:pPr marL="285750" marR="0" indent="-285750">
+              <a:spcBef>
+                <a:spcPts val="0"/>
+              </a:spcBef>
+              <a:spcAft>
+                <a:spcPts val="0"/>
+              </a:spcAft>
+              <a:buFont typeface="Arial" panose="020B0604020202020204" pitchFamily="34" charset="0"/>
+              <a:buChar char="•"/>
+            </a:pPr>
+            <a:r>
+              <a:rPr lang="en-US" sz="1400" dirty="0">
+                <a:latin typeface="Century Gothic" panose="020B0502020202020204" pitchFamily="34" charset="0"/>
+              </a:rPr>
+              <a:t>Username</a:t>
+            </a:r>
+          </a:p>
+          <a:p>
+            <a:pPr marL="285750" marR="0" indent="-285750">
+              <a:spcBef>
+                <a:spcPts val="0"/>
+              </a:spcBef>
+              <a:spcAft>
+                <a:spcPts val="0"/>
+              </a:spcAft>
+              <a:buFont typeface="Arial" panose="020B0604020202020204" pitchFamily="34" charset="0"/>
+              <a:buChar char="•"/>
+            </a:pPr>
+            <a:r>
+              <a:rPr lang="en-US" sz="1400" dirty="0">
+                <a:latin typeface="Century Gothic" panose="020B0502020202020204" pitchFamily="34" charset="0"/>
+              </a:rPr>
+              <a:t>email</a:t>
+            </a:r>
+          </a:p>
+          <a:p>
+            <a:pPr marL="285750" marR="0" indent="-285750">
+              <a:spcBef>
+                <a:spcPts val="0"/>
+              </a:spcBef>
+              <a:spcAft>
+                <a:spcPts val="0"/>
+              </a:spcAft>
+              <a:buFont typeface="Arial" panose="020B0604020202020204" pitchFamily="34" charset="0"/>
+              <a:buChar char="•"/>
+            </a:pPr>
+            <a:r>
+              <a:rPr lang="en-US" sz="1400" dirty="0">
+                <a:effectLst/>
+                <a:latin typeface="Century Gothic" panose="020B0502020202020204" pitchFamily="34" charset="0"/>
+              </a:rPr>
+              <a:t>First Name</a:t>
+            </a:r>
+          </a:p>
+          <a:p>
+            <a:pPr marL="285750" marR="0" indent="-285750">
+              <a:spcBef>
+                <a:spcPts val="0"/>
+              </a:spcBef>
+              <a:spcAft>
+                <a:spcPts val="0"/>
+              </a:spcAft>
+              <a:buFont typeface="Arial" panose="020B0604020202020204" pitchFamily="34" charset="0"/>
+              <a:buChar char="•"/>
+            </a:pPr>
+            <a:r>
+              <a:rPr lang="en-US" sz="1400" dirty="0">
+                <a:effectLst/>
+                <a:latin typeface="Century Gothic" panose="020B0502020202020204" pitchFamily="34" charset="0"/>
+              </a:rPr>
+              <a:t>Last name</a:t>
+            </a:r>
+          </a:p>
+          <a:p>
+            <a:pPr marL="285750" marR="0" indent="-285750">
+              <a:spcBef>
+                <a:spcPts val="0"/>
+              </a:spcBef>
+              <a:spcAft>
+                <a:spcPts val="0"/>
+              </a:spcAft>
+              <a:buFont typeface="Arial" panose="020B0604020202020204" pitchFamily="34" charset="0"/>
+              <a:buChar char="•"/>
+            </a:pPr>
+            <a:r>
+              <a:rPr lang="en-US" sz="1400" dirty="0">
+                <a:effectLst/>
+                <a:latin typeface="Century Gothic" panose="020B0502020202020204" pitchFamily="34" charset="0"/>
+              </a:rPr>
+              <a:t>Password</a:t>
+            </a:r>
+          </a:p>
+        </p:txBody>
+      </p:sp>
+      <p:cxnSp>
+        <p:nvCxnSpPr>
+          <p:cNvPr id="50" name="Straight Arrow Connector 49">
+            <a:extLst>
+              <a:ext uri="{FF2B5EF4-FFF2-40B4-BE49-F238E27FC236}">
+                <a16:creationId xmlns:a16="http://schemas.microsoft.com/office/drawing/2014/main" id="{8200A5C8-9543-C955-6892-B2EC968B7FE1}"/>
+              </a:ext>
+            </a:extLst>
+          </p:cNvPr>
+          <p:cNvCxnSpPr>
+            <a:cxnSpLocks/>
+            <a:stCxn id="49" idx="3"/>
+            <a:endCxn id="48" idx="1"/>
+          </p:cNvCxnSpPr>
+          <p:nvPr/>
+        </p:nvCxnSpPr>
+        <p:spPr>
+          <a:xfrm>
+            <a:off x="8300134" y="4683205"/>
+            <a:ext cx="1698184" cy="1"/>
+          </a:xfrm>
+          <a:prstGeom prst="straightConnector1">
+            <a:avLst/>
+          </a:prstGeom>
+          <a:ln w="38100">
+            <a:tailEnd type="triangle"/>
+          </a:ln>
+        </p:spPr>
+        <p:style>
+          <a:lnRef idx="2">
+            <a:schemeClr val="dk1"/>
+          </a:lnRef>
+          <a:fillRef idx="0">
+            <a:schemeClr val="dk1"/>
+          </a:fillRef>
+          <a:effectRef idx="1">
+            <a:schemeClr val="dk1"/>
+          </a:effectRef>
+          <a:fontRef idx="minor">
+            <a:schemeClr val="tx1"/>
+          </a:fontRef>
+        </p:style>
+      </p:cxnSp>
+      <p:sp>
+        <p:nvSpPr>
+          <p:cNvPr id="55" name="TextBox 54">
+            <a:extLst>
+              <a:ext uri="{FF2B5EF4-FFF2-40B4-BE49-F238E27FC236}">
+                <a16:creationId xmlns:a16="http://schemas.microsoft.com/office/drawing/2014/main" id="{A2A599F8-AC9B-9892-7B66-E81011845A15}"/>
+              </a:ext>
+            </a:extLst>
+          </p:cNvPr>
+          <p:cNvSpPr txBox="1"/>
+          <p:nvPr/>
+        </p:nvSpPr>
+        <p:spPr>
+          <a:xfrm>
+            <a:off x="8300134" y="3467307"/>
+            <a:ext cx="1808293" cy="369332"/>
+          </a:xfrm>
+          <a:prstGeom prst="rect">
+            <a:avLst/>
+          </a:prstGeom>
+          <a:noFill/>
+        </p:spPr>
+        <p:txBody>
+          <a:bodyPr wrap="square" rtlCol="0">
+            <a:spAutoFit/>
+          </a:bodyPr>
+          <a:lstStyle/>
+          <a:p>
+            <a:r>
+              <a:rPr lang="en-US" dirty="0"/>
+              <a:t>Select_related</a:t>
+            </a:r>
+          </a:p>
+        </p:txBody>
+      </p:sp>
+      <p:sp>
+        <p:nvSpPr>
+          <p:cNvPr id="56" name="TextBox 55">
+            <a:extLst>
+              <a:ext uri="{FF2B5EF4-FFF2-40B4-BE49-F238E27FC236}">
+                <a16:creationId xmlns:a16="http://schemas.microsoft.com/office/drawing/2014/main" id="{7194BA93-BAEE-15A8-EF84-B7D919C46F91}"/>
+              </a:ext>
+            </a:extLst>
+          </p:cNvPr>
+          <p:cNvSpPr txBox="1"/>
+          <p:nvPr/>
+        </p:nvSpPr>
+        <p:spPr>
+          <a:xfrm>
+            <a:off x="8212365" y="4780525"/>
+            <a:ext cx="1896062" cy="276999"/>
+          </a:xfrm>
+          <a:prstGeom prst="rect">
+            <a:avLst/>
+          </a:prstGeom>
+          <a:noFill/>
+        </p:spPr>
+        <p:txBody>
+          <a:bodyPr wrap="square" rtlCol="0">
+            <a:spAutoFit/>
+          </a:bodyPr>
+          <a:lstStyle/>
+          <a:p>
+            <a:r>
+              <a:rPr lang="en-US" sz="1200" dirty="0">
+                <a:latin typeface="Century Gothic" panose="020B0502020202020204" pitchFamily="34" charset="0"/>
+              </a:rPr>
+              <a:t>One2One Relationship</a:t>
+            </a:r>
+          </a:p>
+        </p:txBody>
+      </p:sp>
+      <p:sp>
+        <p:nvSpPr>
+          <p:cNvPr id="57" name="TextBox 56">
+            <a:extLst>
+              <a:ext uri="{FF2B5EF4-FFF2-40B4-BE49-F238E27FC236}">
+                <a16:creationId xmlns:a16="http://schemas.microsoft.com/office/drawing/2014/main" id="{A1061CED-1DD4-5BD2-1DFD-B17C90300022}"/>
+              </a:ext>
+            </a:extLst>
+          </p:cNvPr>
+          <p:cNvSpPr txBox="1"/>
+          <p:nvPr/>
+        </p:nvSpPr>
+        <p:spPr>
+          <a:xfrm>
+            <a:off x="2238771" y="2980682"/>
+            <a:ext cx="3606858" cy="430887"/>
+          </a:xfrm>
+          <a:prstGeom prst="rect">
+            <a:avLst/>
+          </a:prstGeom>
+          <a:noFill/>
+        </p:spPr>
+        <p:txBody>
+          <a:bodyPr wrap="square" rtlCol="0">
+            <a:spAutoFit/>
+          </a:bodyPr>
+          <a:lstStyle/>
+          <a:p>
+            <a:r>
+              <a:rPr lang="en-US" sz="1100" dirty="0" err="1"/>
+              <a:t>all_author</a:t>
+            </a:r>
+            <a:r>
+              <a:rPr lang="en-US" sz="1100" dirty="0"/>
+              <a:t>=</a:t>
+            </a:r>
+            <a:r>
+              <a:rPr lang="en-US" sz="1100" dirty="0" err="1"/>
+              <a:t>Author.objects.all</a:t>
+            </a:r>
+            <a:r>
+              <a:rPr lang="en-US" sz="1100" dirty="0"/>
+              <a:t>().</a:t>
+            </a:r>
+            <a:r>
+              <a:rPr lang="en-US" sz="1100" dirty="0" err="1"/>
+              <a:t>prefetch_related</a:t>
+            </a:r>
+            <a:r>
+              <a:rPr lang="en-US" sz="1100" dirty="0"/>
+              <a:t>(“book”)</a:t>
+            </a:r>
+          </a:p>
+          <a:p>
+            <a:r>
+              <a:rPr lang="en-US" sz="1100" dirty="0" err="1"/>
+              <a:t>all_author.book_set.all</a:t>
+            </a:r>
+            <a:endParaRPr lang="en-US" sz="1100" dirty="0"/>
+          </a:p>
+        </p:txBody>
+      </p:sp>
+      <p:sp>
+        <p:nvSpPr>
+          <p:cNvPr id="58" name="TextBox 57">
+            <a:extLst>
+              <a:ext uri="{FF2B5EF4-FFF2-40B4-BE49-F238E27FC236}">
+                <a16:creationId xmlns:a16="http://schemas.microsoft.com/office/drawing/2014/main" id="{EEC7F953-53F2-DF21-7EB3-72DF4CA06F57}"/>
+              </a:ext>
+            </a:extLst>
+          </p:cNvPr>
+          <p:cNvSpPr txBox="1"/>
+          <p:nvPr/>
+        </p:nvSpPr>
+        <p:spPr>
+          <a:xfrm>
+            <a:off x="4948916" y="632440"/>
+            <a:ext cx="707837" cy="261610"/>
+          </a:xfrm>
+          <a:prstGeom prst="rect">
+            <a:avLst/>
+          </a:prstGeom>
+          <a:noFill/>
+        </p:spPr>
+        <p:txBody>
+          <a:bodyPr wrap="square" rtlCol="0">
+            <a:spAutoFit/>
+          </a:bodyPr>
+          <a:lstStyle/>
+          <a:p>
+            <a:r>
+              <a:rPr lang="en-US" sz="1100" dirty="0"/>
+              <a:t>1 Author</a:t>
+            </a:r>
+          </a:p>
+        </p:txBody>
+      </p:sp>
+      <p:sp>
+        <p:nvSpPr>
+          <p:cNvPr id="59" name="TextBox 58">
+            <a:extLst>
+              <a:ext uri="{FF2B5EF4-FFF2-40B4-BE49-F238E27FC236}">
+                <a16:creationId xmlns:a16="http://schemas.microsoft.com/office/drawing/2014/main" id="{AE8D27E3-551F-32A6-6840-2C35CD1980D2}"/>
+              </a:ext>
+            </a:extLst>
+          </p:cNvPr>
+          <p:cNvSpPr txBox="1"/>
+          <p:nvPr/>
+        </p:nvSpPr>
+        <p:spPr>
+          <a:xfrm>
+            <a:off x="368491" y="685215"/>
+            <a:ext cx="978616" cy="261610"/>
+          </a:xfrm>
+          <a:prstGeom prst="rect">
+            <a:avLst/>
+          </a:prstGeom>
+          <a:noFill/>
+        </p:spPr>
+        <p:txBody>
+          <a:bodyPr wrap="square" rtlCol="0">
+            <a:spAutoFit/>
+          </a:bodyPr>
+          <a:lstStyle/>
+          <a:p>
+            <a:r>
+              <a:rPr lang="en-US" sz="1100" dirty="0"/>
+              <a:t>Many books</a:t>
+            </a:r>
+          </a:p>
+        </p:txBody>
+      </p:sp>
+      <p:sp>
+        <p:nvSpPr>
+          <p:cNvPr id="60" name="TextBox 59">
+            <a:extLst>
+              <a:ext uri="{FF2B5EF4-FFF2-40B4-BE49-F238E27FC236}">
+                <a16:creationId xmlns:a16="http://schemas.microsoft.com/office/drawing/2014/main" id="{C8F3E519-2B07-54D3-7A56-5C88657EC8E2}"/>
+              </a:ext>
+            </a:extLst>
+          </p:cNvPr>
+          <p:cNvSpPr txBox="1"/>
+          <p:nvPr/>
+        </p:nvSpPr>
+        <p:spPr>
+          <a:xfrm>
+            <a:off x="1928858" y="877851"/>
+            <a:ext cx="3468986" cy="430887"/>
+          </a:xfrm>
+          <a:prstGeom prst="rect">
+            <a:avLst/>
+          </a:prstGeom>
+          <a:noFill/>
+        </p:spPr>
+        <p:txBody>
+          <a:bodyPr wrap="square" rtlCol="0">
+            <a:spAutoFit/>
+          </a:bodyPr>
+          <a:lstStyle/>
+          <a:p>
+            <a:r>
+              <a:rPr lang="en-US" sz="1100" dirty="0" err="1"/>
+              <a:t>All_books</a:t>
+            </a:r>
+            <a:r>
+              <a:rPr lang="en-US" sz="1100" dirty="0"/>
+              <a:t>=</a:t>
+            </a:r>
+            <a:r>
+              <a:rPr lang="en-US" sz="1100" dirty="0" err="1"/>
+              <a:t>Book.objects.all</a:t>
+            </a:r>
+            <a:r>
+              <a:rPr lang="en-US" sz="1100" dirty="0"/>
+              <a:t>().</a:t>
+            </a:r>
+            <a:r>
+              <a:rPr lang="en-US" sz="1100" dirty="0" err="1"/>
+              <a:t>select_related</a:t>
+            </a:r>
+            <a:r>
+              <a:rPr lang="en-US" sz="1100" dirty="0"/>
+              <a:t>(“author”)</a:t>
+            </a:r>
+          </a:p>
+          <a:p>
+            <a:r>
+              <a:rPr lang="en-US" sz="1100" dirty="0" err="1"/>
+              <a:t>All_books.author</a:t>
+            </a:r>
+            <a:endParaRPr lang="en-US" sz="1100" dirty="0"/>
+          </a:p>
+        </p:txBody>
+      </p:sp>
+      <p:sp>
+        <p:nvSpPr>
+          <p:cNvPr id="61" name="TextBox 60">
+            <a:extLst>
+              <a:ext uri="{FF2B5EF4-FFF2-40B4-BE49-F238E27FC236}">
+                <a16:creationId xmlns:a16="http://schemas.microsoft.com/office/drawing/2014/main" id="{17522A4C-C39C-D313-5875-6DF5B517A0D5}"/>
+              </a:ext>
+            </a:extLst>
+          </p:cNvPr>
+          <p:cNvSpPr txBox="1"/>
+          <p:nvPr/>
+        </p:nvSpPr>
+        <p:spPr>
+          <a:xfrm>
+            <a:off x="2392325" y="300306"/>
+            <a:ext cx="1831535" cy="261610"/>
+          </a:xfrm>
+          <a:prstGeom prst="rect">
+            <a:avLst/>
+          </a:prstGeom>
+          <a:noFill/>
+        </p:spPr>
+        <p:txBody>
+          <a:bodyPr wrap="square" rtlCol="0">
+            <a:spAutoFit/>
+          </a:bodyPr>
+          <a:lstStyle/>
+          <a:p>
+            <a:r>
+              <a:rPr lang="en-US" sz="1100" dirty="0"/>
+              <a:t>1 Author= [a list of books]</a:t>
+            </a:r>
+          </a:p>
+        </p:txBody>
+      </p:sp>
+      <p:sp>
+        <p:nvSpPr>
+          <p:cNvPr id="62" name="TextBox 61">
+            <a:extLst>
+              <a:ext uri="{FF2B5EF4-FFF2-40B4-BE49-F238E27FC236}">
+                <a16:creationId xmlns:a16="http://schemas.microsoft.com/office/drawing/2014/main" id="{F690828C-2988-8865-DA93-CCF9B9667E69}"/>
+              </a:ext>
+            </a:extLst>
+          </p:cNvPr>
+          <p:cNvSpPr txBox="1"/>
+          <p:nvPr/>
+        </p:nvSpPr>
+        <p:spPr>
+          <a:xfrm>
+            <a:off x="2016558" y="5627214"/>
+            <a:ext cx="5015100" cy="769441"/>
+          </a:xfrm>
+          <a:prstGeom prst="rect">
+            <a:avLst/>
+          </a:prstGeom>
+          <a:noFill/>
+        </p:spPr>
+        <p:txBody>
+          <a:bodyPr wrap="square" rtlCol="0">
+            <a:spAutoFit/>
+          </a:bodyPr>
+          <a:lstStyle/>
+          <a:p>
+            <a:r>
+              <a:rPr lang="en-US" sz="1100" dirty="0" err="1"/>
+              <a:t>All_books</a:t>
+            </a:r>
+            <a:r>
+              <a:rPr lang="en-US" sz="1100" dirty="0"/>
+              <a:t>=</a:t>
+            </a:r>
+            <a:r>
+              <a:rPr lang="en-US" sz="1100" dirty="0" err="1"/>
+              <a:t>Book.objects.all</a:t>
+            </a:r>
+            <a:r>
+              <a:rPr lang="en-US" sz="1100" dirty="0"/>
+              <a:t>().</a:t>
+            </a:r>
+            <a:r>
+              <a:rPr lang="en-US" sz="1100" dirty="0" err="1"/>
+              <a:t>select_related</a:t>
+            </a:r>
+            <a:r>
+              <a:rPr lang="en-US" sz="1100" dirty="0"/>
+              <a:t>(“author”).</a:t>
+            </a:r>
+            <a:r>
+              <a:rPr lang="en-US" sz="1100" dirty="0" err="1"/>
+              <a:t>prefetch_related</a:t>
+            </a:r>
+            <a:r>
+              <a:rPr lang="en-US" sz="1100" dirty="0"/>
+              <a:t>(“genre”)</a:t>
+            </a:r>
+          </a:p>
+          <a:p>
+            <a:endParaRPr lang="en-US" sz="1100" dirty="0"/>
+          </a:p>
+          <a:p>
+            <a:r>
+              <a:rPr lang="en-US" sz="1100" dirty="0"/>
+              <a:t>For genre in </a:t>
+            </a:r>
+            <a:r>
+              <a:rPr lang="en-US" sz="1100" dirty="0" err="1"/>
+              <a:t>all_books.genre</a:t>
+            </a:r>
+            <a:r>
+              <a:rPr lang="en-US" sz="1100" dirty="0"/>
+              <a:t>:</a:t>
+            </a:r>
+          </a:p>
+          <a:p>
+            <a:r>
+              <a:rPr lang="en-US" sz="1100" dirty="0"/>
+              <a:t>	genre</a:t>
+            </a:r>
+          </a:p>
+        </p:txBody>
+      </p:sp>
+      <p:sp>
+        <p:nvSpPr>
+          <p:cNvPr id="63" name="TextBox 62">
+            <a:extLst>
+              <a:ext uri="{FF2B5EF4-FFF2-40B4-BE49-F238E27FC236}">
+                <a16:creationId xmlns:a16="http://schemas.microsoft.com/office/drawing/2014/main" id="{516896D7-8AB2-8857-796A-B880918F81B8}"/>
+              </a:ext>
+            </a:extLst>
+          </p:cNvPr>
+          <p:cNvSpPr txBox="1"/>
+          <p:nvPr/>
+        </p:nvSpPr>
+        <p:spPr>
+          <a:xfrm>
+            <a:off x="7630472" y="5637493"/>
+            <a:ext cx="4113890" cy="261610"/>
+          </a:xfrm>
+          <a:prstGeom prst="rect">
+            <a:avLst/>
+          </a:prstGeom>
+          <a:noFill/>
+        </p:spPr>
+        <p:txBody>
+          <a:bodyPr wrap="square" rtlCol="0">
+            <a:spAutoFit/>
+          </a:bodyPr>
+          <a:lstStyle/>
+          <a:p>
+            <a:r>
+              <a:rPr lang="en-US" sz="1100" dirty="0" err="1"/>
+              <a:t>all_userprofile</a:t>
+            </a:r>
+            <a:r>
+              <a:rPr lang="en-US" sz="1100" dirty="0"/>
+              <a:t>=</a:t>
+            </a:r>
+            <a:r>
+              <a:rPr lang="en-US" sz="1100" dirty="0" err="1"/>
+              <a:t>UserProfile.objects.all</a:t>
+            </a:r>
+            <a:r>
+              <a:rPr lang="en-US" sz="1100" dirty="0"/>
+              <a:t>().</a:t>
+            </a:r>
+            <a:r>
+              <a:rPr lang="en-US" sz="1100" dirty="0" err="1"/>
+              <a:t>select_related</a:t>
+            </a:r>
+            <a:r>
+              <a:rPr lang="en-US" sz="1100" dirty="0"/>
+              <a:t>(“user”)</a:t>
+            </a:r>
+          </a:p>
+        </p:txBody>
+      </p:sp>
+    </p:spTree>
+    <p:extLst>
+      <p:ext uri="{BB962C8B-B14F-4D97-AF65-F5344CB8AC3E}">
+        <p14:creationId xmlns:p14="http://schemas.microsoft.com/office/powerpoint/2010/main" val="3214002032"/>
       </p:ext>
     </p:extLst>
   </p:cSld>

</xml_diff>